<commit_message>
Slides: sd-13-012..016 titles at 92/108 and the DevOps và CI/CD group on the cover
Co-Authored-By: Claude Opus 5.5 <noreply@anthropic.com>
Claude-Session: https://claude.ai/code/session_01TQmrJYLm4GPgtXpQaEk7ey
</commit_message>
<xml_diff>
--- a/system-design-101/vi/lessons/sd-13-012/slides/sd-13-012.pptx
+++ b/system-design-101/vi/lessons/sd-13-012/slides/sd-13-012.pptx
@@ -1798,7 +1798,7 @@
         <p:spPr>
           <a:xfrm>
             <a:off x="914400" y="1524000"/>
-            <a:ext cx="8191500" cy="3238500"/>
+            <a:ext cx="8191500" cy="4314825"/>
           </a:xfrm>
           <a:prstGeom prst="rect">
             <a:avLst/>
@@ -1807,17 +1807,17 @@
           <a:ln/>
         </p:spPr>
         <p:txBody>
-          <a:bodyPr wrap="square" lIns="0" tIns="50198" rIns="0" bIns="-50198" rtlCol="0" anchor="t"/>
+          <a:bodyPr wrap="square" lIns="0" tIns="72009" rIns="0" bIns="-72009" rtlCol="0" anchor="t"/>
           <a:lstStyle/>
           <a:p>
             <a:pPr algn="l" indent="0" marL="0">
               <a:lnSpc>
-                <a:spcPts val="5873"/>
+                <a:spcPts val="8424"/>
               </a:lnSpc>
               <a:buNone/>
             </a:pPr>
             <a:r>
-              <a:rPr lang="en-US" sz="5647" dirty="0" spc="2" kern="0">
+              <a:rPr lang="en-US" sz="8100" dirty="0" spc="2" kern="0">
                 <a:solidFill>
                   <a:srgbClr val="F3EEE3"/>
                 </a:solidFill>
@@ -1828,7 +1828,7 @@
               <a:t>Học</a:t>
             </a:r>
             <a:r>
-              <a:rPr lang="en-US" sz="5647" dirty="0" spc="-2" kern="0">
+              <a:rPr lang="en-US" sz="8100" dirty="0" spc="0" kern="0">
                 <a:solidFill>
                   <a:srgbClr val="F3EEE3"/>
                 </a:solidFill>
@@ -1836,10 +1836,10 @@
                 <a:ea typeface="Bricolage Grotesque ExtraBold" pitchFamily="34" charset="-122"/>
                 <a:cs typeface="Bricolage Grotesque ExtraBold" pitchFamily="34" charset="-120"/>
               </a:rPr>
-              <a:t> từ</a:t>
-            </a:r>
-            <a:r>
-              <a:rPr lang="en-US" sz="5647" dirty="0" spc="-1" kern="0">
+              <a:t> từ chuỗi</a:t>
+            </a:r>
+            <a:r>
+              <a:rPr lang="en-US" sz="8100" dirty="0" spc="-36" kern="0">
                 <a:solidFill>
                   <a:srgbClr val="F3EEE3"/>
                 </a:solidFill>
@@ -1847,10 +1847,10 @@
                 <a:ea typeface="Bricolage Grotesque ExtraBold" pitchFamily="34" charset="-122"/>
                 <a:cs typeface="Bricolage Grotesque ExtraBold" pitchFamily="34" charset="-120"/>
               </a:rPr>
-              <a:t> chuỗi</a:t>
-            </a:r>
-            <a:r>
-              <a:rPr lang="en-US" sz="5647" dirty="0" spc="-28" kern="0">
+              <a:t> CI/CD</a:t>
+            </a:r>
+            <a:r>
+              <a:rPr lang="en-US" sz="8100" dirty="0" spc="-1" kern="0">
                 <a:solidFill>
                   <a:srgbClr val="F3EEE3"/>
                 </a:solidFill>
@@ -1858,10 +1858,10 @@
                 <a:ea typeface="Bricolage Grotesque ExtraBold" pitchFamily="34" charset="-122"/>
                 <a:cs typeface="Bricolage Grotesque ExtraBold" pitchFamily="34" charset="-120"/>
               </a:rPr>
-              <a:t> CI/CD</a:t>
-            </a:r>
-            <a:r>
-              <a:rPr lang="en-US" sz="5647" dirty="0" spc="1" kern="0">
+              <a:t> của</a:t>
+            </a:r>
+            <a:r>
+              <a:rPr lang="en-US" sz="8100" dirty="0" spc="0" kern="0">
                 <a:solidFill>
                   <a:srgbClr val="F3EEE3"/>
                 </a:solidFill>
@@ -1869,10 +1869,10 @@
                 <a:ea typeface="Bricolage Grotesque ExtraBold" pitchFamily="34" charset="-122"/>
                 <a:cs typeface="Bricolage Grotesque ExtraBold" pitchFamily="34" charset="-120"/>
               </a:rPr>
-              <a:t> của công ty</a:t>
-            </a:r>
-            <a:r>
-              <a:rPr lang="en-US" sz="5647" dirty="0" spc="-36" kern="0">
+              <a:t> công</a:t>
+            </a:r>
+            <a:r>
+              <a:rPr lang="en-US" sz="8100" dirty="0" spc="2" kern="0">
                 <a:solidFill>
                   <a:srgbClr val="F3EEE3"/>
                 </a:solidFill>
@@ -1880,10 +1880,10 @@
                 <a:ea typeface="Bricolage Grotesque ExtraBold" pitchFamily="34" charset="-122"/>
                 <a:cs typeface="Bricolage Grotesque ExtraBold" pitchFamily="34" charset="-120"/>
               </a:rPr>
-              <a:t> lớn</a:t>
-            </a:r>
-            <a:r>
-              <a:rPr lang="en-US" sz="5647" dirty="0" spc="0" kern="0">
+              <a:t> ty</a:t>
+            </a:r>
+            <a:r>
+              <a:rPr lang="en-US" sz="8100" dirty="0" spc="-53" kern="0">
                 <a:solidFill>
                   <a:srgbClr val="F3EEE3"/>
                 </a:solidFill>
@@ -1891,10 +1891,10 @@
                 <a:ea typeface="Bricolage Grotesque ExtraBold" pitchFamily="34" charset="-122"/>
                 <a:cs typeface="Bricolage Grotesque ExtraBold" pitchFamily="34" charset="-120"/>
               </a:rPr>
-              <a:t> mà không</a:t>
-            </a:r>
-            <a:r>
-              <a:rPr lang="en-US" sz="5647" dirty="0" spc="2" kern="0">
+              <a:t> lớn</a:t>
+            </a:r>
+            <a:r>
+              <a:rPr lang="en-US" sz="8100" dirty="0" spc="1" kern="0">
                 <a:solidFill>
                   <a:srgbClr val="F3EEE3"/>
                 </a:solidFill>
@@ -1902,10 +1902,10 @@
                 <a:ea typeface="Bricolage Grotesque ExtraBold" pitchFamily="34" charset="-122"/>
                 <a:cs typeface="Bricolage Grotesque ExtraBold" pitchFamily="34" charset="-120"/>
               </a:rPr>
-              <a:t> chép</a:t>
-            </a:r>
-            <a:r>
-              <a:rPr lang="en-US" sz="5647" dirty="0" spc="1" kern="0">
+              <a:t> mà</a:t>
+            </a:r>
+            <a:r>
+              <a:rPr lang="en-US" sz="8100" dirty="0" spc="-1" kern="0">
                 <a:solidFill>
                   <a:srgbClr val="F3EEE3"/>
                 </a:solidFill>
@@ -1913,10 +1913,10 @@
                 <a:ea typeface="Bricolage Grotesque ExtraBold" pitchFamily="34" charset="-122"/>
                 <a:cs typeface="Bricolage Grotesque ExtraBold" pitchFamily="34" charset="-120"/>
               </a:rPr>
-              <a:t> công</a:t>
-            </a:r>
-            <a:r>
-              <a:rPr lang="en-US" sz="5647" dirty="0" spc="-1" kern="0">
+              <a:t> không</a:t>
+            </a:r>
+            <a:r>
+              <a:rPr lang="en-US" sz="8100" dirty="0" spc="3" kern="0">
                 <a:solidFill>
                   <a:srgbClr val="F3EEE3"/>
                 </a:solidFill>
@@ -1924,9 +1924,31 @@
                 <a:ea typeface="Bricolage Grotesque ExtraBold" pitchFamily="34" charset="-122"/>
                 <a:cs typeface="Bricolage Grotesque ExtraBold" pitchFamily="34" charset="-120"/>
               </a:rPr>
+              <a:t> chép</a:t>
+            </a:r>
+            <a:r>
+              <a:rPr lang="en-US" sz="8100" dirty="0" spc="1" kern="0">
+                <a:solidFill>
+                  <a:srgbClr val="F3EEE3"/>
+                </a:solidFill>
+                <a:latin typeface="Bricolage Grotesque ExtraBold" pitchFamily="34" charset="0"/>
+                <a:ea typeface="Bricolage Grotesque ExtraBold" pitchFamily="34" charset="-122"/>
+                <a:cs typeface="Bricolage Grotesque ExtraBold" pitchFamily="34" charset="-120"/>
+              </a:rPr>
+              <a:t> công</a:t>
+            </a:r>
+            <a:r>
+              <a:rPr lang="en-US" sz="8100" dirty="0" spc="-1" kern="0">
+                <a:solidFill>
+                  <a:srgbClr val="F3EEE3"/>
+                </a:solidFill>
+                <a:latin typeface="Bricolage Grotesque ExtraBold" pitchFamily="34" charset="0"/>
+                <a:ea typeface="Bricolage Grotesque ExtraBold" pitchFamily="34" charset="-122"/>
+                <a:cs typeface="Bricolage Grotesque ExtraBold" pitchFamily="34" charset="-120"/>
+              </a:rPr>
               <a:t> cụ</a:t>
             </a:r>
-            <a:endParaRPr lang="en-US" sz="5647" dirty="0"/>
+            <a:endParaRPr lang="en-US" sz="8100" dirty="0"/>
           </a:p>
         </p:txBody>
       </p:sp>
@@ -1938,7 +1960,7 @@
         </p:nvSpPr>
         <p:spPr>
           <a:xfrm>
-            <a:off x="914400" y="5143500"/>
+            <a:off x="914400" y="6219825"/>
             <a:ext cx="8191500" cy="1047750"/>
           </a:xfrm>
           <a:prstGeom prst="rect">
@@ -2118,7 +2140,7 @@
               <a:t> nhóm</a:t>
             </a:r>
             <a:r>
-              <a:rPr lang="en-US" sz="1650" dirty="0" spc="-3" kern="0">
+              <a:rPr lang="en-US" sz="1650" dirty="0" spc="-4" kern="0">
                 <a:solidFill>
                   <a:srgbClr val="9AA0B5"/>
                 </a:solidFill>
@@ -2126,10 +2148,10 @@
                 <a:ea typeface="Be Vietnam Pro" pitchFamily="34" charset="-122"/>
                 <a:cs typeface="Be Vietnam Pro" pitchFamily="34" charset="-120"/>
               </a:rPr>
-              <a:t> Quan</a:t>
-            </a:r>
-            <a:r>
-              <a:rPr lang="en-US" sz="1650" dirty="0" spc="-9" kern="0">
+              <a:t> DevOps</a:t>
+            </a:r>
+            <a:r>
+              <a:rPr lang="en-US" sz="1650" dirty="0" spc="-7" kern="0">
                 <a:solidFill>
                   <a:srgbClr val="9AA0B5"/>
                 </a:solidFill>
@@ -2137,7 +2159,7 @@
                 <a:ea typeface="Be Vietnam Pro" pitchFamily="34" charset="-122"/>
                 <a:cs typeface="Be Vietnam Pro" pitchFamily="34" charset="-120"/>
               </a:rPr>
-              <a:t> sát</a:t>
+              <a:t> và</a:t>
             </a:r>
             <a:r>
               <a:rPr lang="en-US" sz="1650" dirty="0" spc="3" kern="0">
@@ -2148,18 +2170,7 @@
                 <a:ea typeface="Be Vietnam Pro" pitchFamily="34" charset="-122"/>
                 <a:cs typeface="Be Vietnam Pro" pitchFamily="34" charset="-120"/>
               </a:rPr>
-              <a:t> hệ</a:t>
-            </a:r>
-            <a:r>
-              <a:rPr lang="en-US" sz="1650" dirty="0" spc="1" kern="0">
-                <a:solidFill>
-                  <a:srgbClr val="9AA0B5"/>
-                </a:solidFill>
-                <a:latin typeface="Be Vietnam Pro" pitchFamily="34" charset="0"/>
-                <a:ea typeface="Be Vietnam Pro" pitchFamily="34" charset="-122"/>
-                <a:cs typeface="Be Vietnam Pro" pitchFamily="34" charset="-120"/>
-              </a:rPr>
-              <a:t> thống</a:t>
+              <a:t> CI/CD</a:t>
             </a:r>
             <a:endParaRPr lang="en-US" sz="1650" dirty="0"/>
           </a:p>
@@ -3048,7 +3059,7 @@
         <p:spPr>
           <a:xfrm>
             <a:off x="914400" y="1333500"/>
-            <a:ext cx="16192500" cy="952500"/>
+            <a:ext cx="16192500" cy="1085850"/>
           </a:xfrm>
           <a:prstGeom prst="rect">
             <a:avLst/>
@@ -3064,7 +3075,7 @@
               <a:buNone/>
             </a:pPr>
             <a:r>
-              <a:rPr lang="en-US" sz="5400" dirty="0" spc="-66" kern="0">
+              <a:rPr lang="en-US" sz="6900" dirty="0" spc="-83" kern="0">
                 <a:solidFill>
                   <a:srgbClr val="F3EEE3"/>
                 </a:solidFill>
@@ -3075,7 +3086,7 @@
               <a:t>Tra</a:t>
             </a:r>
             <a:r>
-              <a:rPr lang="en-US" sz="5400" dirty="0" spc="-2" kern="0">
+              <a:rPr lang="en-US" sz="6900" dirty="0" spc="0" kern="0">
                 <a:solidFill>
                   <a:srgbClr val="F3EEE3"/>
                 </a:solidFill>
@@ -3083,10 +3094,10 @@
                 <a:ea typeface="Bricolage Grotesque ExtraBold" pitchFamily="34" charset="-122"/>
                 <a:cs typeface="Bricolage Grotesque ExtraBold" pitchFamily="34" charset="-120"/>
               </a:rPr>
-              <a:t> lại khi</a:t>
-            </a:r>
-            <a:r>
-              <a:rPr lang="en-US" sz="5400" dirty="0" spc="-3" kern="0">
+              <a:t> lại</a:t>
+            </a:r>
+            <a:r>
+              <a:rPr lang="en-US" sz="6900" dirty="0" spc="1" kern="0">
                 <a:solidFill>
                   <a:srgbClr val="F3EEE3"/>
                 </a:solidFill>
@@ -3094,9 +3105,20 @@
                 <a:ea typeface="Bricolage Grotesque ExtraBold" pitchFamily="34" charset="-122"/>
                 <a:cs typeface="Bricolage Grotesque ExtraBold" pitchFamily="34" charset="-120"/>
               </a:rPr>
+              <a:t> khi</a:t>
+            </a:r>
+            <a:r>
+              <a:rPr lang="en-US" sz="6900" dirty="0" spc="-2" kern="0">
+                <a:solidFill>
+                  <a:srgbClr val="F3EEE3"/>
+                </a:solidFill>
+                <a:latin typeface="Bricolage Grotesque ExtraBold" pitchFamily="34" charset="0"/>
+                <a:ea typeface="Bricolage Grotesque ExtraBold" pitchFamily="34" charset="-122"/>
+                <a:cs typeface="Bricolage Grotesque ExtraBold" pitchFamily="34" charset="-120"/>
+              </a:rPr>
               <a:t> cần</a:t>
             </a:r>
-            <a:endParaRPr lang="en-US" sz="5400" dirty="0"/>
+            <a:endParaRPr lang="en-US" sz="6900" dirty="0"/>
           </a:p>
         </p:txBody>
       </p:sp>
@@ -5040,17 +5062,17 @@
           <a:ln/>
         </p:spPr>
         <p:txBody>
-          <a:bodyPr wrap="square" lIns="0" tIns="32004" rIns="0" bIns="-32004" rtlCol="0" anchor="t"/>
+          <a:bodyPr wrap="square" lIns="0" tIns="35052" rIns="0" bIns="-35052" rtlCol="0" anchor="t"/>
           <a:lstStyle/>
           <a:p>
             <a:pPr algn="l" indent="0" marL="0">
               <a:lnSpc>
-                <a:spcPts val="7056"/>
+                <a:spcPts val="7728"/>
               </a:lnSpc>
               <a:buNone/>
             </a:pPr>
             <a:r>
-              <a:rPr lang="en-US" sz="6300" dirty="0" spc="-95" kern="0">
+              <a:rPr lang="en-US" sz="6900" dirty="0" spc="-110" kern="0">
                 <a:solidFill>
                   <a:srgbClr val="14161C"/>
                 </a:solidFill>
@@ -5061,7 +5083,7 @@
               <a:t>Mượn</a:t>
             </a:r>
             <a:r>
-              <a:rPr lang="en-US" sz="6300" dirty="0" spc="0" kern="0">
+              <a:rPr lang="en-US" sz="6900" dirty="0" spc="-3" kern="0">
                 <a:solidFill>
                   <a:srgbClr val="14161C"/>
                 </a:solidFill>
@@ -5072,7 +5094,7 @@
               <a:t> ý</a:t>
             </a:r>
             <a:r>
-              <a:rPr lang="en-US" sz="6300" dirty="0" spc="-63" kern="0">
+              <a:rPr lang="en-US" sz="6900" dirty="0" spc="-72" kern="0">
                 <a:solidFill>
                   <a:srgbClr val="14161C"/>
                 </a:solidFill>
@@ -5083,7 +5105,7 @@
               <a:t> tưởng</a:t>
             </a:r>
             <a:r>
-              <a:rPr lang="en-US" sz="6300" dirty="0" spc="-62" kern="0">
+              <a:rPr lang="en-US" sz="6900" dirty="0" spc="-70" kern="0">
                 <a:solidFill>
                   <a:srgbClr val="14161C"/>
                 </a:solidFill>
@@ -5094,7 +5116,7 @@
               <a:t> về</a:t>
             </a:r>
             <a:r>
-              <a:rPr lang="en-US" sz="6300" dirty="0" spc="7" kern="0">
+              <a:rPr lang="en-US" sz="6900" dirty="0" spc="10" kern="0">
                 <a:solidFill>
                   <a:srgbClr val="14161C"/>
                 </a:solidFill>
@@ -5105,7 +5127,7 @@
               <a:t> rủi</a:t>
             </a:r>
             <a:r>
-              <a:rPr lang="en-US" sz="6300" dirty="0" spc="-43" kern="0">
+              <a:rPr lang="en-US" sz="6900" dirty="0" spc="-48" kern="0">
                 <a:solidFill>
                   <a:srgbClr val="14161C"/>
                 </a:solidFill>
@@ -5116,7 +5138,7 @@
               <a:t> ro,</a:t>
             </a:r>
             <a:r>
-              <a:rPr lang="en-US" sz="6300" dirty="0" spc="0" kern="0">
+              <a:rPr lang="en-US" sz="6900" dirty="0" spc="0" kern="0">
                 <a:solidFill>
                   <a:srgbClr val="14161C"/>
                 </a:solidFill>
@@ -5127,7 +5149,7 @@
               <a:t> không</a:t>
             </a:r>
             <a:r>
-              <a:rPr lang="en-US" sz="6300" dirty="0" spc="-75" kern="0">
+              <a:rPr lang="en-US" sz="6900" dirty="0" spc="-88" kern="0">
                 <a:solidFill>
                   <a:srgbClr val="14161C"/>
                 </a:solidFill>
@@ -5138,7 +5160,7 @@
               <a:t> mượn</a:t>
             </a:r>
             <a:r>
-              <a:rPr lang="en-US" sz="6300" dirty="0" spc="-1" kern="0">
+              <a:rPr lang="en-US" sz="6900" dirty="0" spc="0" kern="0">
                 <a:solidFill>
                   <a:srgbClr val="14161C"/>
                 </a:solidFill>
@@ -5149,7 +5171,7 @@
               <a:t> công</a:t>
             </a:r>
             <a:r>
-              <a:rPr lang="en-US" sz="6300" dirty="0" spc="-4" kern="0">
+              <a:rPr lang="en-US" sz="6900" dirty="0" spc="-4" kern="0">
                 <a:solidFill>
                   <a:srgbClr val="14161C"/>
                 </a:solidFill>
@@ -5159,7 +5181,7 @@
               </a:rPr>
               <a:t> cụ.</a:t>
             </a:r>
-            <a:endParaRPr lang="en-US" sz="6300" dirty="0"/>
+            <a:endParaRPr lang="en-US" sz="6900" dirty="0"/>
           </a:p>
         </p:txBody>
       </p:sp>
@@ -6065,7 +6087,7 @@
         <p:spPr>
           <a:xfrm>
             <a:off x="914400" y="1333500"/>
-            <a:ext cx="16459200" cy="952500"/>
+            <a:ext cx="16459200" cy="1085850"/>
           </a:xfrm>
           <a:prstGeom prst="rect">
             <a:avLst/>
@@ -6081,7 +6103,7 @@
               <a:buNone/>
             </a:pPr>
             <a:r>
-              <a:rPr lang="en-US" sz="5100" dirty="0" spc="-1" kern="0">
+              <a:rPr lang="en-US" sz="6900" dirty="0" spc="0" kern="0">
                 <a:solidFill>
                   <a:srgbClr val="F3EEE3"/>
                 </a:solidFill>
@@ -6092,7 +6114,7 @@
               <a:t>Thay</a:t>
             </a:r>
             <a:r>
-              <a:rPr lang="en-US" sz="5100" dirty="0" spc="-7" kern="0">
+              <a:rPr lang="en-US" sz="6900" dirty="0" spc="-9" kern="0">
                 <a:solidFill>
                   <a:srgbClr val="F3EEE3"/>
                 </a:solidFill>
@@ -6103,7 +6125,7 @@
               <a:t> máy,</a:t>
             </a:r>
             <a:r>
-              <a:rPr lang="en-US" sz="5100" dirty="0" spc="-12" kern="0">
+              <a:rPr lang="en-US" sz="6900" dirty="0" spc="18" kern="0">
                 <a:solidFill>
                   <a:srgbClr val="F3EEE3"/>
                 </a:solidFill>
@@ -6111,10 +6133,10 @@
                 <a:ea typeface="Bricolage Grotesque ExtraBold" pitchFamily="34" charset="-122"/>
                 <a:cs typeface="Bricolage Grotesque ExtraBold" pitchFamily="34" charset="-120"/>
               </a:rPr>
-              <a:t> rồi</a:t>
-            </a:r>
-            <a:r>
-              <a:rPr lang="en-US" sz="5100" dirty="0" spc="12" kern="0">
+              <a:t> để</a:t>
+            </a:r>
+            <a:r>
+              <a:rPr lang="en-US" sz="6900" dirty="0" spc="0" kern="0">
                 <a:solidFill>
                   <a:srgbClr val="F3EEE3"/>
                 </a:solidFill>
@@ -6122,10 +6144,10 @@
                 <a:ea typeface="Bricolage Grotesque ExtraBold" pitchFamily="34" charset="-122"/>
                 <a:cs typeface="Bricolage Grotesque ExtraBold" pitchFamily="34" charset="-120"/>
               </a:rPr>
-              <a:t> để</a:t>
-            </a:r>
-            <a:r>
-              <a:rPr lang="en-US" sz="5100" dirty="0" spc="0" kern="0">
+              <a:t> quy</a:t>
+            </a:r>
+            <a:r>
+              <a:rPr lang="en-US" sz="6900" dirty="0" spc="-7" kern="0">
                 <a:solidFill>
                   <a:srgbClr val="F3EEE3"/>
                 </a:solidFill>
@@ -6133,10 +6155,10 @@
                 <a:ea typeface="Bricolage Grotesque ExtraBold" pitchFamily="34" charset="-122"/>
                 <a:cs typeface="Bricolage Grotesque ExtraBold" pitchFamily="34" charset="-120"/>
               </a:rPr>
-              <a:t> quy</a:t>
-            </a:r>
-            <a:r>
-              <a:rPr lang="en-US" sz="5100" dirty="0" spc="-5" kern="0">
+              <a:t> tắc</a:t>
+            </a:r>
+            <a:r>
+              <a:rPr lang="en-US" sz="6900" dirty="0" spc="-2" kern="0">
                 <a:solidFill>
                   <a:srgbClr val="F3EEE3"/>
                 </a:solidFill>
@@ -6144,10 +6166,10 @@
                 <a:ea typeface="Bricolage Grotesque ExtraBold" pitchFamily="34" charset="-122"/>
                 <a:cs typeface="Bricolage Grotesque ExtraBold" pitchFamily="34" charset="-120"/>
               </a:rPr>
-              <a:t> tắc</a:t>
-            </a:r>
-            <a:r>
-              <a:rPr lang="en-US" sz="5100" dirty="0" spc="-2" kern="0">
+              <a:t> chấm</a:t>
+            </a:r>
+            <a:r>
+              <a:rPr lang="en-US" sz="6900" dirty="0" spc="6" kern="0">
                 <a:solidFill>
                   <a:srgbClr val="F3EEE3"/>
                 </a:solidFill>
@@ -6155,20 +6177,9 @@
                 <a:ea typeface="Bricolage Grotesque ExtraBold" pitchFamily="34" charset="-122"/>
                 <a:cs typeface="Bricolage Grotesque ExtraBold" pitchFamily="34" charset="-120"/>
               </a:rPr>
-              <a:t> chấm</a:t>
-            </a:r>
-            <a:r>
-              <a:rPr lang="en-US" sz="5100" dirty="0" spc="5" kern="0">
-                <a:solidFill>
-                  <a:srgbClr val="F3EEE3"/>
-                </a:solidFill>
-                <a:latin typeface="Bricolage Grotesque ExtraBold" pitchFamily="34" charset="0"/>
-                <a:ea typeface="Bricolage Grotesque ExtraBold" pitchFamily="34" charset="-122"/>
-                <a:cs typeface="Bricolage Grotesque ExtraBold" pitchFamily="34" charset="-120"/>
-              </a:rPr>
               <a:t> canary</a:t>
             </a:r>
-            <a:endParaRPr lang="en-US" sz="5100" dirty="0"/>
+            <a:endParaRPr lang="en-US" sz="6900" dirty="0"/>
           </a:p>
         </p:txBody>
       </p:sp>
@@ -7518,7 +7529,7 @@
         <p:spPr>
           <a:xfrm>
             <a:off x="914400" y="1333500"/>
-            <a:ext cx="16459200" cy="952500"/>
+            <a:ext cx="16459200" cy="1085850"/>
           </a:xfrm>
           <a:prstGeom prst="rect">
             <a:avLst/>
@@ -7534,7 +7545,7 @@
               <a:buNone/>
             </a:pPr>
             <a:r>
-              <a:rPr lang="en-US" sz="5100" dirty="0" spc="-98" kern="0">
+              <a:rPr lang="en-US" sz="6900" dirty="0" spc="-129" kern="0">
                 <a:solidFill>
                   <a:srgbClr val="14161C"/>
                 </a:solidFill>
@@ -7545,7 +7556,7 @@
               <a:t>Test</a:t>
             </a:r>
             <a:r>
-              <a:rPr lang="en-US" sz="5100" dirty="0" spc="0" kern="0">
+              <a:rPr lang="en-US" sz="6900" dirty="0" spc="-1" kern="0">
                 <a:solidFill>
                   <a:srgbClr val="14161C"/>
                 </a:solidFill>
@@ -7556,7 +7567,7 @@
               <a:t> chập</a:t>
             </a:r>
             <a:r>
-              <a:rPr lang="en-US" sz="5100" dirty="0" spc="-26" kern="0">
+              <a:rPr lang="en-US" sz="6900" dirty="0" spc="-29" kern="0">
                 <a:solidFill>
                   <a:srgbClr val="14161C"/>
                 </a:solidFill>
@@ -7564,10 +7575,10 @@
                 <a:ea typeface="Bricolage Grotesque ExtraBold" pitchFamily="34" charset="-122"/>
                 <a:cs typeface="Bricolage Grotesque ExtraBold" pitchFamily="34" charset="-120"/>
               </a:rPr>
-              <a:t> chờn</a:t>
-            </a:r>
-            <a:r>
-              <a:rPr lang="en-US" sz="5100" dirty="0" spc="-1" kern="0">
+              <a:t> chờn:</a:t>
+            </a:r>
+            <a:r>
+              <a:rPr lang="en-US" sz="6900" dirty="0" spc="-1" kern="0">
                 <a:solidFill>
                   <a:srgbClr val="14161C"/>
                 </a:solidFill>
@@ -7575,10 +7586,10 @@
                 <a:ea typeface="Bricolage Grotesque ExtraBold" pitchFamily="34" charset="-122"/>
                 <a:cs typeface="Bricolage Grotesque ExtraBold" pitchFamily="34" charset="-120"/>
               </a:rPr>
-              <a:t> làm</a:t>
-            </a:r>
-            <a:r>
-              <a:rPr lang="en-US" sz="5100" dirty="0" spc="-2" kern="0">
+              <a:t> mất</a:t>
+            </a:r>
+            <a:r>
+              <a:rPr lang="en-US" sz="6900" dirty="0" spc="2" kern="0">
                 <a:solidFill>
                   <a:srgbClr val="14161C"/>
                 </a:solidFill>
@@ -7586,10 +7597,10 @@
                 <a:ea typeface="Bricolage Grotesque ExtraBold" pitchFamily="34" charset="-122"/>
                 <a:cs typeface="Bricolage Grotesque ExtraBold" pitchFamily="34" charset="-120"/>
               </a:rPr>
-              <a:t> mất</a:t>
-            </a:r>
-            <a:r>
-              <a:rPr lang="en-US" sz="5100" dirty="0" spc="2" kern="0">
+              <a:t> tin</a:t>
+            </a:r>
+            <a:r>
+              <a:rPr lang="en-US" sz="6900" dirty="0" spc="-39" kern="0">
                 <a:solidFill>
                   <a:srgbClr val="14161C"/>
                 </a:solidFill>
@@ -7597,10 +7608,10 @@
                 <a:ea typeface="Bricolage Grotesque ExtraBold" pitchFamily="34" charset="-122"/>
                 <a:cs typeface="Bricolage Grotesque ExtraBold" pitchFamily="34" charset="-120"/>
               </a:rPr>
-              <a:t> tin</a:t>
-            </a:r>
-            <a:r>
-              <a:rPr lang="en-US" sz="5100" dirty="0" spc="-41" kern="0">
+              <a:t> kết</a:t>
+            </a:r>
+            <a:r>
+              <a:rPr lang="en-US" sz="6900" dirty="0" spc="0" kern="0">
                 <a:solidFill>
                   <a:srgbClr val="14161C"/>
                 </a:solidFill>
@@ -7608,31 +7619,9 @@
                 <a:ea typeface="Bricolage Grotesque ExtraBold" pitchFamily="34" charset="-122"/>
                 <a:cs typeface="Bricolage Grotesque ExtraBold" pitchFamily="34" charset="-120"/>
               </a:rPr>
-              <a:t> vào</a:t>
-            </a:r>
-            <a:r>
-              <a:rPr lang="en-US" sz="5100" dirty="0" spc="-30" kern="0">
-                <a:solidFill>
-                  <a:srgbClr val="14161C"/>
-                </a:solidFill>
-                <a:latin typeface="Bricolage Grotesque ExtraBold" pitchFamily="34" charset="0"/>
-                <a:ea typeface="Bricolage Grotesque ExtraBold" pitchFamily="34" charset="-122"/>
-                <a:cs typeface="Bricolage Grotesque ExtraBold" pitchFamily="34" charset="-120"/>
-              </a:rPr>
-              <a:t> kết</a:t>
-            </a:r>
-            <a:r>
-              <a:rPr lang="en-US" sz="5100" dirty="0" spc="0" kern="0">
-                <a:solidFill>
-                  <a:srgbClr val="14161C"/>
-                </a:solidFill>
-                <a:latin typeface="Bricolage Grotesque ExtraBold" pitchFamily="34" charset="0"/>
-                <a:ea typeface="Bricolage Grotesque ExtraBold" pitchFamily="34" charset="-122"/>
-                <a:cs typeface="Bricolage Grotesque ExtraBold" pitchFamily="34" charset="-120"/>
-              </a:rPr>
               <a:t> quả</a:t>
             </a:r>
-            <a:endParaRPr lang="en-US" sz="5100" dirty="0"/>
+            <a:endParaRPr lang="en-US" sz="6900" dirty="0"/>
           </a:p>
         </p:txBody>
       </p:sp>
@@ -8913,7 +8902,7 @@
         <p:spPr>
           <a:xfrm>
             <a:off x="914400" y="1333500"/>
-            <a:ext cx="16459200" cy="952500"/>
+            <a:ext cx="16459200" cy="1085850"/>
           </a:xfrm>
           <a:prstGeom prst="rect">
             <a:avLst/>
@@ -8929,7 +8918,7 @@
               <a:buNone/>
             </a:pPr>
             <a:r>
-              <a:rPr lang="en-US" sz="5100" dirty="0" spc="3" kern="0">
+              <a:rPr lang="en-US" sz="6900" dirty="0" spc="-1" kern="0">
                 <a:solidFill>
                   <a:srgbClr val="14161C"/>
                 </a:solidFill>
@@ -8937,10 +8926,10 @@
                 <a:ea typeface="Bricolage Grotesque ExtraBold" pitchFamily="34" charset="-122"/>
                 <a:cs typeface="Bricolage Grotesque ExtraBold" pitchFamily="34" charset="-120"/>
               </a:rPr>
-              <a:t>Bí</a:t>
-            </a:r>
-            <a:r>
-              <a:rPr lang="en-US" sz="5100" dirty="0" spc="-2" kern="0">
+              <a:t>Bí mật từ</a:t>
+            </a:r>
+            <a:r>
+              <a:rPr lang="en-US" sz="6900" dirty="0" spc="-22" kern="0">
                 <a:solidFill>
                   <a:srgbClr val="14161C"/>
                 </a:solidFill>
@@ -8948,10 +8937,10 @@
                 <a:ea typeface="Bricolage Grotesque ExtraBold" pitchFamily="34" charset="-122"/>
                 <a:cs typeface="Bricolage Grotesque ExtraBold" pitchFamily="34" charset="-120"/>
               </a:rPr>
-              <a:t> mật</a:t>
-            </a:r>
-            <a:r>
-              <a:rPr lang="en-US" sz="5100" dirty="0" spc="28" kern="0">
+              <a:t> kho,</a:t>
+            </a:r>
+            <a:r>
+              <a:rPr lang="en-US" sz="6900" dirty="0" spc="0" kern="0">
                 <a:solidFill>
                   <a:srgbClr val="14161C"/>
                 </a:solidFill>
@@ -8959,10 +8948,10 @@
                 <a:ea typeface="Bricolage Grotesque ExtraBold" pitchFamily="34" charset="-122"/>
                 <a:cs typeface="Bricolage Grotesque ExtraBold" pitchFamily="34" charset="-120"/>
               </a:rPr>
-              <a:t> đi</a:t>
-            </a:r>
-            <a:r>
-              <a:rPr lang="en-US" sz="5100" dirty="0" spc="0" kern="0">
+              <a:t> không</a:t>
+            </a:r>
+            <a:r>
+              <a:rPr lang="en-US" sz="6900" dirty="0" spc="-13" kern="0">
                 <a:solidFill>
                   <a:srgbClr val="14161C"/>
                 </a:solidFill>
@@ -8970,10 +8959,10 @@
                 <a:ea typeface="Bricolage Grotesque ExtraBold" pitchFamily="34" charset="-122"/>
                 <a:cs typeface="Bricolage Grotesque ExtraBold" pitchFamily="34" charset="-120"/>
               </a:rPr>
-              <a:t> từ</a:t>
-            </a:r>
-            <a:r>
-              <a:rPr lang="en-US" sz="5100" dirty="0" spc="-16" kern="0">
+              <a:t> trong</a:t>
+            </a:r>
+            <a:r>
+              <a:rPr lang="en-US" sz="6900" dirty="0" spc="-2" kern="0">
                 <a:solidFill>
                   <a:srgbClr val="14161C"/>
                 </a:solidFill>
@@ -8981,53 +8970,9 @@
                 <a:ea typeface="Bricolage Grotesque ExtraBold" pitchFamily="34" charset="-122"/>
                 <a:cs typeface="Bricolage Grotesque ExtraBold" pitchFamily="34" charset="-120"/>
               </a:rPr>
-              <a:t> kho,</a:t>
-            </a:r>
-            <a:r>
-              <a:rPr lang="en-US" sz="5100" dirty="0" spc="1" kern="0">
-                <a:solidFill>
-                  <a:srgbClr val="14161C"/>
-                </a:solidFill>
-                <a:latin typeface="Bricolage Grotesque ExtraBold" pitchFamily="34" charset="0"/>
-                <a:ea typeface="Bricolage Grotesque ExtraBold" pitchFamily="34" charset="-122"/>
-                <a:cs typeface="Bricolage Grotesque ExtraBold" pitchFamily="34" charset="-120"/>
-              </a:rPr>
-              <a:t> không</a:t>
-            </a:r>
-            <a:r>
-              <a:rPr lang="en-US" sz="5100" dirty="0" spc="0" kern="0">
-                <a:solidFill>
-                  <a:srgbClr val="14161C"/>
-                </a:solidFill>
-                <a:latin typeface="Bricolage Grotesque ExtraBold" pitchFamily="34" charset="0"/>
-                <a:ea typeface="Bricolage Grotesque ExtraBold" pitchFamily="34" charset="-122"/>
-                <a:cs typeface="Bricolage Grotesque ExtraBold" pitchFamily="34" charset="-120"/>
-              </a:rPr>
-              <a:t> nằm</a:t>
-            </a:r>
-            <a:r>
-              <a:rPr lang="en-US" sz="5100" dirty="0" spc="-8" kern="0">
-                <a:solidFill>
-                  <a:srgbClr val="14161C"/>
-                </a:solidFill>
-                <a:latin typeface="Bricolage Grotesque ExtraBold" pitchFamily="34" charset="0"/>
-                <a:ea typeface="Bricolage Grotesque ExtraBold" pitchFamily="34" charset="-122"/>
-                <a:cs typeface="Bricolage Grotesque ExtraBold" pitchFamily="34" charset="-120"/>
-              </a:rPr>
-              <a:t> trong</a:t>
-            </a:r>
-            <a:r>
-              <a:rPr lang="en-US" sz="5100" dirty="0" spc="-4" kern="0">
-                <a:solidFill>
-                  <a:srgbClr val="14161C"/>
-                </a:solidFill>
-                <a:latin typeface="Bricolage Grotesque ExtraBold" pitchFamily="34" charset="0"/>
-                <a:ea typeface="Bricolage Grotesque ExtraBold" pitchFamily="34" charset="-122"/>
-                <a:cs typeface="Bricolage Grotesque ExtraBold" pitchFamily="34" charset="-120"/>
-              </a:rPr>
               <a:t> mã</a:t>
             </a:r>
-            <a:endParaRPr lang="en-US" sz="5100" dirty="0"/>
+            <a:endParaRPr lang="en-US" sz="6900" dirty="0"/>
           </a:p>
         </p:txBody>
       </p:sp>
@@ -10295,7 +10240,7 @@
         <p:spPr>
           <a:xfrm>
             <a:off x="914400" y="1333500"/>
-            <a:ext cx="16459200" cy="952500"/>
+            <a:ext cx="16459200" cy="1085850"/>
           </a:xfrm>
           <a:prstGeom prst="rect">
             <a:avLst/>
@@ -10311,7 +10256,7 @@
               <a:buNone/>
             </a:pPr>
             <a:r>
-              <a:rPr lang="en-US" sz="5100" dirty="0" spc="3" kern="0">
+              <a:rPr lang="en-US" sz="6900" dirty="0" spc="5" kern="0">
                 <a:solidFill>
                   <a:srgbClr val="F3EEE3"/>
                 </a:solidFill>
@@ -10322,7 +10267,7 @@
               <a:t>Phụ</a:t>
             </a:r>
             <a:r>
-              <a:rPr lang="en-US" sz="5100" dirty="0" spc="1" kern="0">
+              <a:rPr lang="en-US" sz="6900" dirty="0" spc="1" kern="0">
                 <a:solidFill>
                   <a:srgbClr val="F3EEE3"/>
                 </a:solidFill>
@@ -10333,7 +10278,7 @@
               <a:t> thuộc</a:t>
             </a:r>
             <a:r>
-              <a:rPr lang="en-US" sz="5100" dirty="0" spc="12" kern="0">
+              <a:rPr lang="en-US" sz="6900" dirty="0" spc="13" kern="0">
                 <a:solidFill>
                   <a:srgbClr val="F3EEE3"/>
                 </a:solidFill>
@@ -10344,7 +10289,7 @@
               <a:t> đổi</a:t>
             </a:r>
             <a:r>
-              <a:rPr lang="en-US" sz="5100" dirty="0" spc="-58" kern="0">
+              <a:rPr lang="en-US" sz="6900" dirty="0" spc="-80" kern="0">
                 <a:solidFill>
                   <a:srgbClr val="F3EEE3"/>
                 </a:solidFill>
@@ -10355,7 +10300,7 @@
               <a:t> dưới</a:t>
             </a:r>
             <a:r>
-              <a:rPr lang="en-US" sz="5100" dirty="0" spc="-1" kern="0">
+              <a:rPr lang="en-US" sz="6900" dirty="0" spc="0" kern="0">
                 <a:solidFill>
                   <a:srgbClr val="F3EEE3"/>
                 </a:solidFill>
@@ -10365,7 +10310,7 @@
               </a:rPr>
               <a:t> chân</a:t>
             </a:r>
-            <a:endParaRPr lang="en-US" sz="5100" dirty="0"/>
+            <a:endParaRPr lang="en-US" sz="6900" dirty="0"/>
           </a:p>
         </p:txBody>
       </p:sp>
@@ -11455,7 +11400,7 @@
         <p:spPr>
           <a:xfrm>
             <a:off x="914400" y="1333500"/>
-            <a:ext cx="16459200" cy="952500"/>
+            <a:ext cx="16459200" cy="1085850"/>
           </a:xfrm>
           <a:prstGeom prst="rect">
             <a:avLst/>
@@ -11471,7 +11416,7 @@
               <a:buNone/>
             </a:pPr>
             <a:r>
-              <a:rPr lang="en-US" sz="5100" dirty="0" spc="-80" kern="0">
+              <a:rPr lang="en-US" sz="6900" dirty="0" spc="-110" kern="0">
                 <a:solidFill>
                   <a:srgbClr val="14161C"/>
                 </a:solidFill>
@@ -11482,7 +11427,7 @@
               <a:t>Mượn</a:t>
             </a:r>
             <a:r>
-              <a:rPr lang="en-US" sz="5100" dirty="0" spc="-1" kern="0">
+              <a:rPr lang="en-US" sz="6900" dirty="0" spc="-3" kern="0">
                 <a:solidFill>
                   <a:srgbClr val="14161C"/>
                 </a:solidFill>
@@ -11493,7 +11438,7 @@
               <a:t> ý</a:t>
             </a:r>
             <a:r>
-              <a:rPr lang="en-US" sz="5100" dirty="0" spc="-33" kern="0">
+              <a:rPr lang="en-US" sz="6900" dirty="0" spc="-45" kern="0">
                 <a:solidFill>
                   <a:srgbClr val="14161C"/>
                 </a:solidFill>
@@ -11504,7 +11449,7 @@
               <a:t> tưởng,</a:t>
             </a:r>
             <a:r>
-              <a:rPr lang="en-US" sz="5100" dirty="0" spc="0" kern="0">
+              <a:rPr lang="en-US" sz="6900" dirty="0" spc="0" kern="0">
                 <a:solidFill>
                   <a:srgbClr val="14161C"/>
                 </a:solidFill>
@@ -11515,7 +11460,7 @@
               <a:t> không</a:t>
             </a:r>
             <a:r>
-              <a:rPr lang="en-US" sz="5100" dirty="0" spc="-65" kern="0">
+              <a:rPr lang="en-US" sz="6900" dirty="0" spc="-88" kern="0">
                 <a:solidFill>
                   <a:srgbClr val="14161C"/>
                 </a:solidFill>
@@ -11526,7 +11471,7 @@
               <a:t> mượn</a:t>
             </a:r>
             <a:r>
-              <a:rPr lang="en-US" sz="5100" dirty="0" spc="-30" kern="0">
+              <a:rPr lang="en-US" sz="6900" dirty="0" spc="-39" kern="0">
                 <a:solidFill>
                   <a:srgbClr val="14161C"/>
                 </a:solidFill>
@@ -11537,7 +11482,7 @@
               <a:t> kết</a:t>
             </a:r>
             <a:r>
-              <a:rPr lang="en-US" sz="5100" dirty="0" spc="1" kern="0">
+              <a:rPr lang="en-US" sz="6900" dirty="0" spc="2" kern="0">
                 <a:solidFill>
                   <a:srgbClr val="14161C"/>
                 </a:solidFill>
@@ -11547,7 +11492,7 @@
               </a:rPr>
               <a:t> luận</a:t>
             </a:r>
-            <a:endParaRPr lang="en-US" sz="5100" dirty="0"/>
+            <a:endParaRPr lang="en-US" sz="6900" dirty="0"/>
           </a:p>
         </p:txBody>
       </p:sp>
@@ -12581,7 +12526,7 @@
         <p:spPr>
           <a:xfrm>
             <a:off x="914400" y="1333500"/>
-            <a:ext cx="16459200" cy="952500"/>
+            <a:ext cx="16459200" cy="1085850"/>
           </a:xfrm>
           <a:prstGeom prst="rect">
             <a:avLst/>
@@ -12597,7 +12542,7 @@
               <a:buNone/>
             </a:pPr>
             <a:r>
-              <a:rPr lang="en-US" sz="4800" dirty="0" spc="-3" kern="0">
+              <a:rPr lang="en-US" sz="6900" dirty="0" spc="-1" kern="0">
                 <a:solidFill>
                   <a:srgbClr val="14161C"/>
                 </a:solidFill>
@@ -12605,10 +12550,10 @@
                 <a:ea typeface="Bricolage Grotesque ExtraBold" pitchFamily="34" charset="-122"/>
                 <a:cs typeface="Bricolage Grotesque ExtraBold" pitchFamily="34" charset="-120"/>
               </a:rPr>
-              <a:t>Vì</a:t>
-            </a:r>
-            <a:r>
-              <a:rPr lang="en-US" sz="4800" dirty="0" spc="-4" kern="0">
+              <a:t>Sao</a:t>
+            </a:r>
+            <a:r>
+              <a:rPr lang="en-US" sz="6900" dirty="0" spc="0" kern="0">
                 <a:solidFill>
                   <a:srgbClr val="14161C"/>
                 </a:solidFill>
@@ -12616,10 +12561,10 @@
                 <a:ea typeface="Bricolage Grotesque ExtraBold" pitchFamily="34" charset="-122"/>
                 <a:cs typeface="Bricolage Grotesque ExtraBold" pitchFamily="34" charset="-120"/>
               </a:rPr>
-              <a:t> sao</a:t>
-            </a:r>
-            <a:r>
-              <a:rPr lang="en-US" sz="4800" dirty="0" spc="0" kern="0">
+              <a:t> thay</a:t>
+            </a:r>
+            <a:r>
+              <a:rPr lang="en-US" sz="6900" dirty="0" spc="-26" kern="0">
                 <a:solidFill>
                   <a:srgbClr val="14161C"/>
                 </a:solidFill>
@@ -12627,10 +12572,10 @@
                 <a:ea typeface="Bricolage Grotesque ExtraBold" pitchFamily="34" charset="-122"/>
                 <a:cs typeface="Bricolage Grotesque ExtraBold" pitchFamily="34" charset="-120"/>
               </a:rPr>
-              <a:t> thay</a:t>
-            </a:r>
-            <a:r>
-              <a:rPr lang="en-US" sz="4800" dirty="0" spc="-20" kern="0">
+              <a:t> image</a:t>
+            </a:r>
+            <a:r>
+              <a:rPr lang="en-US" sz="6900" dirty="0" spc="0" kern="0">
                 <a:solidFill>
                   <a:srgbClr val="14161C"/>
                 </a:solidFill>
@@ -12638,10 +12583,10 @@
                 <a:ea typeface="Bricolage Grotesque ExtraBold" pitchFamily="34" charset="-122"/>
                 <a:cs typeface="Bricolage Grotesque ExtraBold" pitchFamily="34" charset="-120"/>
               </a:rPr>
-              <a:t> image</a:t>
-            </a:r>
-            <a:r>
-              <a:rPr lang="en-US" sz="4800" dirty="0" spc="-2" kern="0">
+              <a:t> an</a:t>
+            </a:r>
+            <a:r>
+              <a:rPr lang="en-US" sz="6900" dirty="0" spc="-31" kern="0">
                 <a:solidFill>
                   <a:srgbClr val="14161C"/>
                 </a:solidFill>
@@ -12649,10 +12594,10 @@
                 <a:ea typeface="Bricolage Grotesque ExtraBold" pitchFamily="34" charset="-122"/>
                 <a:cs typeface="Bricolage Grotesque ExtraBold" pitchFamily="34" charset="-120"/>
               </a:rPr>
-              <a:t> an</a:t>
-            </a:r>
-            <a:r>
-              <a:rPr lang="en-US" sz="4800" dirty="0" spc="-24" kern="0">
+              <a:t> toàn</a:t>
+            </a:r>
+            <a:r>
+              <a:rPr lang="en-US" sz="6900" dirty="0" spc="-55" kern="0">
                 <a:solidFill>
                   <a:srgbClr val="14161C"/>
                 </a:solidFill>
@@ -12660,53 +12605,9 @@
                 <a:ea typeface="Bricolage Grotesque ExtraBold" pitchFamily="34" charset="-122"/>
                 <a:cs typeface="Bricolage Grotesque ExtraBold" pitchFamily="34" charset="-120"/>
               </a:rPr>
-              <a:t> toàn</a:t>
-            </a:r>
-            <a:r>
-              <a:rPr lang="en-US" sz="4800" dirty="0" spc="-32" kern="0">
-                <a:solidFill>
-                  <a:srgbClr val="14161C"/>
-                </a:solidFill>
-                <a:latin typeface="Bricolage Grotesque ExtraBold" pitchFamily="34" charset="0"/>
-                <a:ea typeface="Bricolage Grotesque ExtraBold" pitchFamily="34" charset="-122"/>
-                <a:cs typeface="Bricolage Grotesque ExtraBold" pitchFamily="34" charset="-120"/>
-              </a:rPr>
-              <a:t> hơn</a:t>
-            </a:r>
-            <a:r>
-              <a:rPr lang="en-US" sz="4800" dirty="0" spc="-41" kern="0">
-                <a:solidFill>
-                  <a:srgbClr val="14161C"/>
-                </a:solidFill>
-                <a:latin typeface="Bricolage Grotesque ExtraBold" pitchFamily="34" charset="0"/>
-                <a:ea typeface="Bricolage Grotesque ExtraBold" pitchFamily="34" charset="-122"/>
-                <a:cs typeface="Bricolage Grotesque ExtraBold" pitchFamily="34" charset="-120"/>
-              </a:rPr>
-              <a:t> sửa</a:t>
-            </a:r>
-            <a:r>
-              <a:rPr lang="en-US" sz="4800" dirty="0" spc="-5" kern="0">
-                <a:solidFill>
-                  <a:srgbClr val="14161C"/>
-                </a:solidFill>
-                <a:latin typeface="Bricolage Grotesque ExtraBold" pitchFamily="34" charset="0"/>
-                <a:ea typeface="Bricolage Grotesque ExtraBold" pitchFamily="34" charset="-122"/>
-                <a:cs typeface="Bricolage Grotesque ExtraBold" pitchFamily="34" charset="-120"/>
-              </a:rPr>
-              <a:t> tại</a:t>
-            </a:r>
-            <a:r>
-              <a:rPr lang="en-US" sz="4800" dirty="0" spc="-29" kern="0">
-                <a:solidFill>
-                  <a:srgbClr val="14161C"/>
-                </a:solidFill>
-                <a:latin typeface="Bricolage Grotesque ExtraBold" pitchFamily="34" charset="0"/>
-                <a:ea typeface="Bricolage Grotesque ExtraBold" pitchFamily="34" charset="-122"/>
-                <a:cs typeface="Bricolage Grotesque ExtraBold" pitchFamily="34" charset="-120"/>
-              </a:rPr>
-              <a:t> chỗ?</a:t>
-            </a:r>
-            <a:endParaRPr lang="en-US" sz="4800" dirty="0"/>
+              <a:t> hơn?</a:t>
+            </a:r>
+            <a:endParaRPr lang="en-US" sz="6900" dirty="0"/>
           </a:p>
         </p:txBody>
       </p:sp>
@@ -14015,7 +13916,7 @@
         <p:spPr>
           <a:xfrm>
             <a:off x="914400" y="1333500"/>
-            <a:ext cx="16459200" cy="952500"/>
+            <a:ext cx="16459200" cy="1085850"/>
           </a:xfrm>
           <a:prstGeom prst="rect">
             <a:avLst/>
@@ -14031,7 +13932,7 @@
               <a:buNone/>
             </a:pPr>
             <a:r>
-              <a:rPr lang="en-US" sz="5100" dirty="0" spc="-2" kern="0">
+              <a:rPr lang="en-US" sz="6900" dirty="0" spc="-2" kern="0">
                 <a:solidFill>
                   <a:srgbClr val="F3EEE3"/>
                 </a:solidFill>
@@ -14042,7 +13943,7 @@
               <a:t>Năm</a:t>
             </a:r>
             <a:r>
-              <a:rPr lang="en-US" sz="5100" dirty="0" spc="-10" kern="0">
+              <a:rPr lang="en-US" sz="6900" dirty="0" spc="-15" kern="0">
                 <a:solidFill>
                   <a:srgbClr val="F3EEE3"/>
                 </a:solidFill>
@@ -14053,7 +13954,7 @@
               <a:t> ý,</a:t>
             </a:r>
             <a:r>
-              <a:rPr lang="en-US" sz="5100" dirty="0" spc="1" kern="0">
+              <a:rPr lang="en-US" sz="6900" dirty="0" spc="0" kern="0">
                 <a:solidFill>
                   <a:srgbClr val="F3EEE3"/>
                 </a:solidFill>
@@ -14064,7 +13965,7 @@
               <a:t> mỗi</a:t>
             </a:r>
             <a:r>
-              <a:rPr lang="en-US" sz="5100" dirty="0" spc="-1" kern="0">
+              <a:rPr lang="en-US" sz="6900" dirty="0" spc="-3" kern="0">
                 <a:solidFill>
                   <a:srgbClr val="F3EEE3"/>
                 </a:solidFill>
@@ -14075,7 +13976,7 @@
               <a:t> ý</a:t>
             </a:r>
             <a:r>
-              <a:rPr lang="en-US" sz="5100" dirty="0" spc="-7" kern="0">
+              <a:rPr lang="en-US" sz="6900" dirty="0" spc="-11" kern="0">
                 <a:solidFill>
                   <a:srgbClr val="F3EEE3"/>
                 </a:solidFill>
@@ -14086,7 +13987,7 @@
               <a:t> một</a:t>
             </a:r>
             <a:r>
-              <a:rPr lang="en-US" sz="5100" dirty="0" spc="1" kern="0">
+              <a:rPr lang="en-US" sz="6900" dirty="0" spc="0" kern="0">
                 <a:solidFill>
                   <a:srgbClr val="F3EEE3"/>
                 </a:solidFill>
@@ -14097,7 +13998,7 @@
               <a:t> việc</a:t>
             </a:r>
             <a:r>
-              <a:rPr lang="en-US" sz="5100" dirty="0" spc="-1" kern="0">
+              <a:rPr lang="en-US" sz="6900" dirty="0" spc="-2" kern="0">
                 <a:solidFill>
                   <a:srgbClr val="F3EEE3"/>
                 </a:solidFill>
@@ -14107,7 +14008,7 @@
               </a:rPr>
               <a:t> làm</a:t>
             </a:r>
-            <a:endParaRPr lang="en-US" sz="5100" dirty="0"/>
+            <a:endParaRPr lang="en-US" sz="6900" dirty="0"/>
           </a:p>
         </p:txBody>
       </p:sp>

</xml_diff>

<commit_message>
Slides: sd-13-012..016 body text at 34 px
Co-Authored-By: Claude Opus 5.5 <noreply@anthropic.com>
Claude-Session: https://claude.ai/code/session_01TQmrJYLm4GPgtXpQaEk7ey
</commit_message>
<xml_diff>
--- a/system-design-101/vi/lessons/sd-13-012/slides/sd-13-012.pptx
+++ b/system-design-101/vi/lessons/sd-13-012/slides/sd-13-012.pptx
@@ -9157,17 +9157,17 @@
           <a:ln/>
         </p:spPr>
         <p:txBody>
-          <a:bodyPr wrap="square" lIns="0" tIns="8557" rIns="0" bIns="-8557" rtlCol="0" anchor="t"/>
+          <a:bodyPr wrap="square" lIns="0" tIns="9700" rIns="0" bIns="-9700" rtlCol="0" anchor="t"/>
           <a:lstStyle/>
           <a:p>
             <a:pPr algn="l" indent="0" marL="0">
               <a:lnSpc>
-                <a:spcPts val="3038"/>
+                <a:spcPts val="3443"/>
               </a:lnSpc>
               <a:buNone/>
             </a:pPr>
             <a:r>
-              <a:rPr lang="en-US" sz="2250" dirty="0" spc="-2" kern="0">
+              <a:rPr lang="en-US" sz="2550" dirty="0" spc="1" kern="0">
                 <a:solidFill>
                   <a:srgbClr val="14161C"/>
                 </a:solidFill>
@@ -9178,7 +9178,7 @@
               <a:t>Quản</a:t>
             </a:r>
             <a:r>
-              <a:rPr lang="en-US" sz="2250" dirty="0" spc="2" kern="0">
+              <a:rPr lang="en-US" sz="2550" dirty="0" spc="-1" kern="0">
                 <a:solidFill>
                   <a:srgbClr val="14161C"/>
                 </a:solidFill>
@@ -9189,7 +9189,7 @@
               <a:t> lý</a:t>
             </a:r>
             <a:r>
-              <a:rPr lang="en-US" sz="2250" dirty="0" spc="-17" kern="0">
+              <a:rPr lang="en-US" sz="2550" dirty="0" spc="-18" kern="0">
                 <a:solidFill>
                   <a:srgbClr val="14161C"/>
                 </a:solidFill>
@@ -9200,7 +9200,7 @@
               <a:t> và</a:t>
             </a:r>
             <a:r>
-              <a:rPr lang="en-US" sz="2250" dirty="0" spc="2" kern="0">
+              <a:rPr lang="en-US" sz="2550" dirty="0" spc="0" kern="0">
                 <a:solidFill>
                   <a:srgbClr val="14161C"/>
                 </a:solidFill>
@@ -9208,10 +9208,10 @@
                 <a:ea typeface="Be Vietnam Pro" pitchFamily="34" charset="-122"/>
                 <a:cs typeface="Be Vietnam Pro" pitchFamily="34" charset="-120"/>
               </a:rPr>
-              <a:t> cấp bí</a:t>
-            </a:r>
-            <a:r>
-              <a:rPr lang="en-US" sz="2250" dirty="0" spc="-9" kern="0">
+              <a:t> cấp</a:t>
+            </a:r>
+            <a:r>
+              <a:rPr lang="en-US" sz="2550" dirty="0" spc="1" kern="0">
                 <a:solidFill>
                   <a:srgbClr val="14161C"/>
                 </a:solidFill>
@@ -9219,9 +9219,20 @@
                 <a:ea typeface="Be Vietnam Pro" pitchFamily="34" charset="-122"/>
                 <a:cs typeface="Be Vietnam Pro" pitchFamily="34" charset="-120"/>
               </a:rPr>
+              <a:t> bí</a:t>
+            </a:r>
+            <a:r>
+              <a:rPr lang="en-US" sz="2550" dirty="0" spc="-8" kern="0">
+                <a:solidFill>
+                  <a:srgbClr val="14161C"/>
+                </a:solidFill>
+                <a:latin typeface="Be Vietnam Pro" pitchFamily="34" charset="0"/>
+                <a:ea typeface="Be Vietnam Pro" pitchFamily="34" charset="-122"/>
+                <a:cs typeface="Be Vietnam Pro" pitchFamily="34" charset="-120"/>
+              </a:rPr>
               <a:t> mật.</a:t>
             </a:r>
-            <a:endParaRPr lang="en-US" sz="2250" dirty="0"/>
+            <a:endParaRPr lang="en-US" sz="2550" dirty="0"/>
           </a:p>
         </p:txBody>
       </p:sp>
@@ -9309,12 +9320,12 @@
           <a:ln/>
         </p:spPr>
         <p:txBody>
-          <a:bodyPr wrap="square" lIns="0" tIns="8557" rIns="0" bIns="-8557" rtlCol="0" anchor="t"/>
+          <a:bodyPr wrap="square" lIns="0" tIns="9700" rIns="0" bIns="-9700" rtlCol="0" anchor="t"/>
           <a:lstStyle/>
           <a:p>
-            <a:pPr algn="l" marL="285750" indent="-204151">
+            <a:pPr algn="l" marL="323850" indent="-231371">
               <a:lnSpc>
-                <a:spcPts val="3038"/>
+                <a:spcPts val="3443"/>
               </a:lnSpc>
               <a:spcAft>
                 <a:spcPts val="450"/>
@@ -9324,7 +9335,7 @@
               <a:buChar char="•"/>
             </a:pPr>
             <a:r>
-              <a:rPr lang="en-US" sz="2250" dirty="0" spc="-17" kern="0">
+              <a:rPr lang="en-US" sz="2550" dirty="0" spc="-17" kern="0">
                 <a:solidFill>
                   <a:srgbClr val="14161C"/>
                 </a:solidFill>
@@ -9335,7 +9346,7 @@
               <a:t>Quyền</a:t>
             </a:r>
             <a:r>
-              <a:rPr lang="en-US" sz="2250" dirty="0" spc="-10" kern="0">
+              <a:rPr lang="en-US" sz="2550" dirty="0" spc="-13" kern="0">
                 <a:solidFill>
                   <a:srgbClr val="14161C"/>
                 </a:solidFill>
@@ -9346,7 +9357,7 @@
               <a:t> tối</a:t>
             </a:r>
             <a:r>
-              <a:rPr lang="en-US" sz="2250" dirty="0" spc="-1" kern="0">
+              <a:rPr lang="en-US" sz="2550" dirty="0" spc="2" kern="0">
                 <a:solidFill>
                   <a:srgbClr val="14161C"/>
                 </a:solidFill>
@@ -9356,19 +9367,19 @@
               </a:rPr>
               <a:t> thiểu</a:t>
             </a:r>
-            <a:endParaRPr lang="en-US" sz="2250" dirty="0"/>
+            <a:endParaRPr lang="en-US" sz="2550" dirty="0"/>
           </a:p>
           <a:p>
-            <a:pPr algn="l" marL="285750" indent="-204151">
+            <a:pPr algn="l" marL="323850" indent="-231371">
               <a:lnSpc>
-                <a:spcPts val="3038"/>
+                <a:spcPts val="3443"/>
               </a:lnSpc>
               <a:buSzPct val="100000"/>
               <a:buFont typeface="Arial"/>
               <a:buChar char="•"/>
             </a:pPr>
             <a:r>
-              <a:rPr lang="en-US" sz="2250" dirty="0" spc="-1" kern="0">
+              <a:rPr lang="en-US" sz="2550" dirty="0" spc="-2" kern="0">
                 <a:solidFill>
                   <a:srgbClr val="14161C"/>
                 </a:solidFill>
@@ -9379,7 +9390,7 @@
               <a:t>Thời</a:t>
             </a:r>
             <a:r>
-              <a:rPr lang="en-US" sz="2250" dirty="0" spc="0" kern="0">
+              <a:rPr lang="en-US" sz="2550" dirty="0" spc="0" kern="0">
                 <a:solidFill>
                   <a:srgbClr val="14161C"/>
                 </a:solidFill>
@@ -9390,7 +9401,7 @@
               <a:t> hạn</a:t>
             </a:r>
             <a:r>
-              <a:rPr lang="en-US" sz="2250" dirty="0" spc="-9" kern="0">
+              <a:rPr lang="en-US" sz="2550" dirty="0" spc="-10" kern="0">
                 <a:solidFill>
                   <a:srgbClr val="14161C"/>
                 </a:solidFill>
@@ -9400,7 +9411,7 @@
               </a:rPr>
               <a:t> ngắn</a:t>
             </a:r>
-            <a:endParaRPr lang="en-US" sz="2250" dirty="0"/>
+            <a:endParaRPr lang="en-US" sz="2550" dirty="0"/>
           </a:p>
         </p:txBody>
       </p:sp>
@@ -9506,7 +9517,7 @@
               <a:buNone/>
             </a:pPr>
             <a:r>
-              <a:rPr lang="en-US" sz="2250" dirty="0" spc="1" kern="0">
+              <a:rPr lang="en-US" sz="2550" dirty="0" spc="-1" kern="0">
                 <a:solidFill>
                   <a:srgbClr val="6B6A66"/>
                 </a:solidFill>
@@ -9517,7 +9528,7 @@
               <a:t>Không</a:t>
             </a:r>
             <a:r>
-              <a:rPr lang="en-US" sz="2250" dirty="0" spc="8" kern="0">
+              <a:rPr lang="en-US" sz="2550" dirty="0" spc="6" kern="0">
                 <a:solidFill>
                   <a:srgbClr val="6B6A66"/>
                 </a:solidFill>
@@ -9528,7 +9539,7 @@
               <a:t> chứa</a:t>
             </a:r>
             <a:r>
-              <a:rPr lang="en-US" sz="2250" dirty="0" spc="2" kern="0">
+              <a:rPr lang="en-US" sz="2550" dirty="0" spc="1" kern="0">
                 <a:solidFill>
                   <a:srgbClr val="6B6A66"/>
                 </a:solidFill>
@@ -9539,7 +9550,7 @@
               <a:t> bí</a:t>
             </a:r>
             <a:r>
-              <a:rPr lang="en-US" sz="2250" dirty="0" spc="-8" kern="0">
+              <a:rPr lang="en-US" sz="2550" dirty="0" spc="-8" kern="0">
                 <a:solidFill>
                   <a:srgbClr val="6B6A66"/>
                 </a:solidFill>
@@ -9549,7 +9560,7 @@
               </a:rPr>
               <a:t> mật.</a:t>
             </a:r>
-            <a:endParaRPr lang="en-US" sz="2250" dirty="0"/>
+            <a:endParaRPr lang="en-US" sz="2550" dirty="0"/>
           </a:p>
         </p:txBody>
       </p:sp>
@@ -9655,7 +9666,7 @@
               <a:buNone/>
             </a:pPr>
             <a:r>
-              <a:rPr lang="en-US" sz="2250" dirty="0" spc="1" kern="0">
+              <a:rPr lang="en-US" sz="2550" dirty="0" spc="-1" kern="0">
                 <a:solidFill>
                   <a:srgbClr val="6B6A66"/>
                 </a:solidFill>
@@ -9666,7 +9677,7 @@
               <a:t>Không</a:t>
             </a:r>
             <a:r>
-              <a:rPr lang="en-US" sz="2250" dirty="0" spc="0" kern="0">
+              <a:rPr lang="en-US" sz="2550" dirty="0" spc="-2" kern="0">
                 <a:solidFill>
                   <a:srgbClr val="6B6A66"/>
                 </a:solidFill>
@@ -9677,7 +9688,7 @@
               <a:t> in</a:t>
             </a:r>
             <a:r>
-              <a:rPr lang="en-US" sz="2250" dirty="0" spc="2" kern="0">
+              <a:rPr lang="en-US" sz="2550" dirty="0" spc="1" kern="0">
                 <a:solidFill>
                   <a:srgbClr val="6B6A66"/>
                 </a:solidFill>
@@ -9688,7 +9699,7 @@
               <a:t> bí</a:t>
             </a:r>
             <a:r>
-              <a:rPr lang="en-US" sz="2250" dirty="0" spc="-12" kern="0">
+              <a:rPr lang="en-US" sz="2550" dirty="0" spc="-11" kern="0">
                 <a:solidFill>
                   <a:srgbClr val="6B6A66"/>
                 </a:solidFill>
@@ -9699,7 +9710,7 @@
               <a:t> mật</a:t>
             </a:r>
             <a:r>
-              <a:rPr lang="en-US" sz="2250" dirty="0" spc="-23" kern="0">
+              <a:rPr lang="en-US" sz="2550" dirty="0" spc="-25" kern="0">
                 <a:solidFill>
                   <a:srgbClr val="6B6A66"/>
                 </a:solidFill>
@@ -9709,7 +9720,7 @@
               </a:rPr>
               <a:t> ra.</a:t>
             </a:r>
-            <a:endParaRPr lang="en-US" sz="2250" dirty="0"/>
+            <a:endParaRPr lang="en-US" sz="2550" dirty="0"/>
           </a:p>
         </p:txBody>
       </p:sp>
@@ -10427,7 +10438,7 @@
               <a:buNone/>
             </a:pPr>
             <a:r>
-              <a:rPr lang="en-US" sz="2400" dirty="0" spc="1" kern="0">
+              <a:rPr lang="en-US" sz="2550" dirty="0" spc="-1" kern="0">
                 <a:solidFill>
                   <a:srgbClr val="E4E1D8"/>
                 </a:solidFill>
@@ -10438,7 +10449,7 @@
               <a:t>Kiểm</a:t>
             </a:r>
             <a:r>
-              <a:rPr lang="en-US" sz="2400" dirty="0" spc="-21" kern="0">
+              <a:rPr lang="en-US" sz="2550" dirty="0" spc="-25" kern="0">
                 <a:solidFill>
                   <a:srgbClr val="E4E1D8"/>
                 </a:solidFill>
@@ -10449,7 +10460,7 @@
               <a:t> tra</a:t>
             </a:r>
             <a:r>
-              <a:rPr lang="en-US" sz="2400" dirty="0" spc="1" kern="0">
+              <a:rPr lang="en-US" sz="2550" dirty="0" spc="1" kern="0">
                 <a:solidFill>
                   <a:srgbClr val="E4E1D8"/>
                 </a:solidFill>
@@ -10460,7 +10471,7 @@
               <a:t> nguồn</a:t>
             </a:r>
             <a:r>
-              <a:rPr lang="en-US" sz="2400" dirty="0" spc="-13" kern="0">
+              <a:rPr lang="en-US" sz="2550" dirty="0" spc="-16" kern="0">
                 <a:solidFill>
                   <a:srgbClr val="E4E1D8"/>
                 </a:solidFill>
@@ -10471,7 +10482,7 @@
               <a:t> gốc</a:t>
             </a:r>
             <a:r>
-              <a:rPr lang="en-US" sz="2400" dirty="0" spc="6" kern="0">
+              <a:rPr lang="en-US" sz="2550" dirty="0" spc="6" kern="0">
                 <a:solidFill>
                   <a:srgbClr val="E4E1D8"/>
                 </a:solidFill>
@@ -10482,7 +10493,7 @@
               <a:t> trước</a:t>
             </a:r>
             <a:r>
-              <a:rPr lang="en-US" sz="2400" dirty="0" spc="-2" kern="0">
+              <a:rPr lang="en-US" sz="2550" dirty="0" spc="0" kern="0">
                 <a:solidFill>
                   <a:srgbClr val="E4E1D8"/>
                 </a:solidFill>
@@ -10490,20 +10501,9 @@
                 <a:ea typeface="Be Vietnam Pro" pitchFamily="34" charset="-122"/>
                 <a:cs typeface="Be Vietnam Pro" pitchFamily="34" charset="-120"/>
               </a:rPr>
-              <a:t> khi</a:t>
-            </a:r>
-            <a:r>
-              <a:rPr lang="en-US" sz="2400" dirty="0" spc="2" kern="0">
-                <a:solidFill>
-                  <a:srgbClr val="E4E1D8"/>
-                </a:solidFill>
-                <a:latin typeface="Be Vietnam Pro" pitchFamily="34" charset="0"/>
-                <a:ea typeface="Be Vietnam Pro" pitchFamily="34" charset="-122"/>
-                <a:cs typeface="Be Vietnam Pro" pitchFamily="34" charset="-120"/>
-              </a:rPr>
-              <a:t> dùng.</a:t>
-            </a:r>
-            <a:endParaRPr lang="en-US" sz="2400" dirty="0"/>
+              <a:t> khi dùng.</a:t>
+            </a:r>
+            <a:endParaRPr lang="en-US" sz="2550" dirty="0"/>
           </a:p>
         </p:txBody>
       </p:sp>
@@ -10631,7 +10631,7 @@
               <a:buNone/>
             </a:pPr>
             <a:r>
-              <a:rPr lang="en-US" sz="2400" dirty="0" spc="-1" kern="0">
+              <a:rPr lang="en-US" sz="2550" dirty="0" spc="-5" kern="0">
                 <a:solidFill>
                   <a:srgbClr val="E4E1D8"/>
                 </a:solidFill>
@@ -10642,7 +10642,7 @@
               <a:t>Khóa</a:t>
             </a:r>
             <a:r>
-              <a:rPr lang="en-US" sz="2400" dirty="0" spc="0" kern="0">
+              <a:rPr lang="en-US" sz="2550" dirty="0" spc="0" kern="0">
                 <a:solidFill>
                   <a:srgbClr val="E4E1D8"/>
                 </a:solidFill>
@@ -10650,10 +10650,10 @@
                 <a:ea typeface="Be Vietnam Pro" pitchFamily="34" charset="-122"/>
                 <a:cs typeface="Be Vietnam Pro" pitchFamily="34" charset="-120"/>
               </a:rPr>
-              <a:t> phiên bản,</a:t>
-            </a:r>
-            <a:r>
-              <a:rPr lang="en-US" sz="2400" dirty="0" spc="1" kern="0">
+              <a:t> phiên</a:t>
+            </a:r>
+            <a:r>
+              <a:rPr lang="en-US" sz="2550" dirty="0" spc="-3" kern="0">
                 <a:solidFill>
                   <a:srgbClr val="E4E1D8"/>
                 </a:solidFill>
@@ -10661,10 +10661,21 @@
                 <a:ea typeface="Be Vietnam Pro" pitchFamily="34" charset="-122"/>
                 <a:cs typeface="Be Vietnam Pro" pitchFamily="34" charset="-120"/>
               </a:rPr>
+              <a:t> bản,</a:t>
+            </a:r>
+            <a:r>
+              <a:rPr lang="en-US" sz="2550" dirty="0" spc="0" kern="0">
+                <a:solidFill>
+                  <a:srgbClr val="E4E1D8"/>
+                </a:solidFill>
+                <a:latin typeface="Be Vietnam Pro" pitchFamily="34" charset="0"/>
+                <a:ea typeface="Be Vietnam Pro" pitchFamily="34" charset="-122"/>
+                <a:cs typeface="Be Vietnam Pro" pitchFamily="34" charset="-120"/>
+              </a:rPr>
               <a:t> không</a:t>
             </a:r>
             <a:r>
-              <a:rPr lang="en-US" sz="2400" dirty="0" spc="3" kern="0">
+              <a:rPr lang="en-US" sz="2550" dirty="0" spc="-1" kern="0">
                 <a:solidFill>
                   <a:srgbClr val="E4E1D8"/>
                 </a:solidFill>
@@ -10675,7 +10686,7 @@
               <a:t> tự</a:t>
             </a:r>
             <a:r>
-              <a:rPr lang="en-US" sz="2400" dirty="0" spc="9" kern="0">
+              <a:rPr lang="en-US" sz="2550" dirty="0" spc="11" kern="0">
                 <a:solidFill>
                   <a:srgbClr val="E4E1D8"/>
                 </a:solidFill>
@@ -10685,7 +10696,7 @@
               </a:rPr>
               <a:t> đổi.</a:t>
             </a:r>
-            <a:endParaRPr lang="en-US" sz="2400" dirty="0"/>
+            <a:endParaRPr lang="en-US" sz="2550" dirty="0"/>
           </a:p>
         </p:txBody>
       </p:sp>
@@ -10802,7 +10813,7 @@
               <a:buNone/>
             </a:pPr>
             <a:r>
-              <a:rPr lang="en-US" sz="2400" dirty="0" spc="1" kern="0">
+              <a:rPr lang="en-US" sz="2550" dirty="0" spc="0" kern="0">
                 <a:solidFill>
                   <a:srgbClr val="E4E1D8"/>
                 </a:solidFill>
@@ -10813,7 +10824,7 @@
               <a:t>Khung</a:t>
             </a:r>
             <a:r>
-              <a:rPr lang="en-US" sz="2400" dirty="0" spc="-9" kern="0">
+              <a:rPr lang="en-US" sz="2550" dirty="0" spc="-12" kern="0">
                 <a:solidFill>
                   <a:srgbClr val="E4E1D8"/>
                 </a:solidFill>
@@ -10824,7 +10835,7 @@
               <a:t> SLSA</a:t>
             </a:r>
             <a:r>
-              <a:rPr lang="en-US" sz="2400" dirty="0" spc="-16" kern="0">
+              <a:rPr lang="en-US" sz="2550" dirty="0" spc="-18" kern="0">
                 <a:solidFill>
                   <a:srgbClr val="E4E1D8"/>
                 </a:solidFill>
@@ -10835,7 +10846,7 @@
               <a:t> và</a:t>
             </a:r>
             <a:r>
-              <a:rPr lang="en-US" sz="2400" dirty="0" spc="2" kern="0">
+              <a:rPr lang="en-US" sz="2550" dirty="0" spc="-1" kern="0">
                 <a:solidFill>
                   <a:srgbClr val="E4E1D8"/>
                 </a:solidFill>
@@ -10846,7 +10857,7 @@
               <a:t> danh</a:t>
             </a:r>
             <a:r>
-              <a:rPr lang="en-US" sz="2400" dirty="0" spc="-6" kern="0">
+              <a:rPr lang="en-US" sz="2550" dirty="0" spc="-5" kern="0">
                 <a:solidFill>
                   <a:srgbClr val="E4E1D8"/>
                 </a:solidFill>
@@ -10857,7 +10868,7 @@
               <a:t> sách</a:t>
             </a:r>
             <a:r>
-              <a:rPr lang="en-US" sz="2400" dirty="0" spc="2" kern="0">
+              <a:rPr lang="en-US" sz="2550" dirty="0" spc="-3" kern="0">
                 <a:solidFill>
                   <a:srgbClr val="E4E1D8"/>
                 </a:solidFill>
@@ -10868,7 +10879,7 @@
               <a:t> rủi</a:t>
             </a:r>
             <a:r>
-              <a:rPr lang="en-US" sz="2400" dirty="0" spc="-29" kern="0">
+              <a:rPr lang="en-US" sz="2550" dirty="0" spc="-34" kern="0">
                 <a:solidFill>
                   <a:srgbClr val="E4E1D8"/>
                 </a:solidFill>
@@ -10879,7 +10890,7 @@
               <a:t> ro</a:t>
             </a:r>
             <a:r>
-              <a:rPr lang="en-US" sz="2400" dirty="0" spc="-46" kern="0">
+              <a:rPr lang="en-US" sz="2550" dirty="0" spc="-48" kern="0">
                 <a:solidFill>
                   <a:srgbClr val="E4E1D8"/>
                 </a:solidFill>
@@ -10889,7 +10900,7 @@
               </a:rPr>
               <a:t> OWASP.</a:t>
             </a:r>
-            <a:endParaRPr lang="en-US" sz="2400" dirty="0"/>
+            <a:endParaRPr lang="en-US" sz="2550" dirty="0"/>
           </a:p>
         </p:txBody>
       </p:sp>
@@ -14118,17 +14129,17 @@
           <a:ln/>
         </p:spPr>
         <p:txBody>
-          <a:bodyPr wrap="square" lIns="0" tIns="5334" rIns="0" bIns="-5334" rtlCol="0" anchor="t"/>
+          <a:bodyPr wrap="square" lIns="0" tIns="5667" rIns="0" bIns="-5667" rtlCol="0" anchor="t"/>
           <a:lstStyle/>
           <a:p>
             <a:pPr algn="l" indent="0" marL="0">
               <a:lnSpc>
-                <a:spcPts val="3360"/>
+                <a:spcPts val="3570"/>
               </a:lnSpc>
               <a:buNone/>
             </a:pPr>
             <a:r>
-              <a:rPr lang="en-US" sz="2400" dirty="0" spc="-70" kern="0">
+              <a:rPr lang="en-US" sz="2550" dirty="0" spc="-77" kern="0">
                 <a:solidFill>
                   <a:srgbClr val="E4E1D8"/>
                 </a:solidFill>
@@ -14139,7 +14150,7 @@
               <a:t>Tạo</a:t>
             </a:r>
             <a:r>
-              <a:rPr lang="en-US" sz="2400" dirty="0" spc="-1" kern="0">
+              <a:rPr lang="en-US" sz="2550" dirty="0" spc="-3" kern="0">
                 <a:solidFill>
                   <a:srgbClr val="E4E1D8"/>
                 </a:solidFill>
@@ -14150,7 +14161,7 @@
               <a:t> bản</a:t>
             </a:r>
             <a:r>
-              <a:rPr lang="en-US" sz="2400" dirty="0" spc="2" kern="0">
+              <a:rPr lang="en-US" sz="2550" dirty="0" spc="-1" kern="0">
                 <a:solidFill>
                   <a:srgbClr val="E4E1D8"/>
                 </a:solidFill>
@@ -14161,7 +14172,7 @@
               <a:t> mới</a:t>
             </a:r>
             <a:r>
-              <a:rPr lang="en-US" sz="2400" dirty="0" spc="3" kern="0">
+              <a:rPr lang="en-US" sz="2550" dirty="0" spc="0" kern="0">
                 <a:solidFill>
                   <a:srgbClr val="E4E1D8"/>
                 </a:solidFill>
@@ -14172,7 +14183,7 @@
               <a:t> từ</a:t>
             </a:r>
             <a:r>
-              <a:rPr lang="en-US" sz="2400" dirty="0" spc="20" kern="0">
+              <a:rPr lang="en-US" sz="2550" dirty="0" spc="20" kern="0">
                 <a:solidFill>
                   <a:srgbClr val="E4E1D8"/>
                 </a:solidFill>
@@ -14183,7 +14194,7 @@
               <a:t> định</a:t>
             </a:r>
             <a:r>
-              <a:rPr lang="en-US" sz="2400" dirty="0" spc="2" kern="0">
+              <a:rPr lang="en-US" sz="2550" dirty="0" spc="0" kern="0">
                 <a:solidFill>
                   <a:srgbClr val="E4E1D8"/>
                 </a:solidFill>
@@ -14194,7 +14205,7 @@
               <a:t> nghĩa,</a:t>
             </a:r>
             <a:r>
-              <a:rPr lang="en-US" sz="2400" dirty="0" spc="-24" kern="0">
+              <a:rPr lang="en-US" sz="2550" dirty="0" spc="-26" kern="0">
                 <a:solidFill>
                   <a:srgbClr val="E4E1D8"/>
                 </a:solidFill>
@@ -14205,7 +14216,7 @@
               <a:t> rồi</a:t>
             </a:r>
             <a:r>
-              <a:rPr lang="en-US" sz="2400" dirty="0" spc="-6" kern="0">
+              <a:rPr lang="en-US" sz="2550" dirty="0" spc="-7" kern="0">
                 <a:solidFill>
                   <a:srgbClr val="E4E1D8"/>
                 </a:solidFill>
@@ -14216,7 +14227,7 @@
               <a:t> thay</a:t>
             </a:r>
             <a:r>
-              <a:rPr lang="en-US" sz="2400" dirty="0" spc="0" kern="0">
+              <a:rPr lang="en-US" sz="2550" dirty="0" spc="2" kern="0">
                 <a:solidFill>
                   <a:srgbClr val="E4E1D8"/>
                 </a:solidFill>
@@ -14226,7 +14237,7 @@
               </a:rPr>
               <a:t> thế.</a:t>
             </a:r>
-            <a:endParaRPr lang="en-US" sz="2400" dirty="0"/>
+            <a:endParaRPr lang="en-US" sz="2550" dirty="0"/>
           </a:p>
         </p:txBody>
       </p:sp>
@@ -14336,17 +14347,17 @@
           <a:ln/>
         </p:spPr>
         <p:txBody>
-          <a:bodyPr wrap="square" lIns="0" tIns="5334" rIns="0" bIns="-5334" rtlCol="0" anchor="t"/>
+          <a:bodyPr wrap="square" lIns="0" tIns="5667" rIns="0" bIns="-5667" rtlCol="0" anchor="t"/>
           <a:lstStyle/>
           <a:p>
             <a:pPr algn="l" indent="0" marL="0">
               <a:lnSpc>
-                <a:spcPts val="3360"/>
+                <a:spcPts val="3570"/>
               </a:lnSpc>
               <a:buNone/>
             </a:pPr>
             <a:r>
-              <a:rPr lang="en-US" sz="2400" dirty="0" spc="1" kern="0">
+              <a:rPr lang="en-US" sz="2550" dirty="0" spc="-3" kern="0">
                 <a:solidFill>
                   <a:srgbClr val="E4E1D8"/>
                 </a:solidFill>
@@ -14357,7 +14368,7 @@
               <a:t>So</a:t>
             </a:r>
             <a:r>
-              <a:rPr lang="en-US" sz="2400" dirty="0" spc="-8" kern="0">
+              <a:rPr lang="en-US" sz="2550" dirty="0" spc="-10" kern="0">
                 <a:solidFill>
                   <a:srgbClr val="E4E1D8"/>
                 </a:solidFill>
@@ -14368,7 +14379,7 @@
               <a:t> số</a:t>
             </a:r>
             <a:r>
-              <a:rPr lang="en-US" sz="2400" dirty="0" spc="18" kern="0">
+              <a:rPr lang="en-US" sz="2550" dirty="0" spc="16" kern="0">
                 <a:solidFill>
                   <a:srgbClr val="E4E1D8"/>
                 </a:solidFill>
@@ -14379,7 +14390,7 @@
               <a:t> đo</a:t>
             </a:r>
             <a:r>
-              <a:rPr lang="en-US" sz="2400" dirty="0" spc="-13" kern="0">
+              <a:rPr lang="en-US" sz="2550" dirty="0" spc="-15" kern="0">
                 <a:solidFill>
                   <a:srgbClr val="E4E1D8"/>
                 </a:solidFill>
@@ -14390,7 +14401,7 @@
               <a:t> với</a:t>
             </a:r>
             <a:r>
-              <a:rPr lang="en-US" sz="2400" dirty="0" spc="12" kern="0">
+              <a:rPr lang="en-US" sz="2550" dirty="0" spc="13" kern="0">
                 <a:solidFill>
                   <a:srgbClr val="E4E1D8"/>
                 </a:solidFill>
@@ -14401,7 +14412,7 @@
               <a:t> đối</a:t>
             </a:r>
             <a:r>
-              <a:rPr lang="en-US" sz="2400" dirty="0" spc="18" kern="0">
+              <a:rPr lang="en-US" sz="2550" dirty="0" spc="16" kern="0">
                 <a:solidFill>
                   <a:srgbClr val="E4E1D8"/>
                 </a:solidFill>
@@ -14412,7 +14423,7 @@
               <a:t> chứng</a:t>
             </a:r>
             <a:r>
-              <a:rPr lang="en-US" sz="2400" dirty="0" spc="-2" kern="0">
+              <a:rPr lang="en-US" sz="2550" dirty="0" spc="-2" kern="0">
                 <a:solidFill>
                   <a:srgbClr val="E4E1D8"/>
                 </a:solidFill>
@@ -14423,7 +14434,7 @@
               <a:t> theo</a:t>
             </a:r>
             <a:r>
-              <a:rPr lang="en-US" sz="2400" dirty="0" spc="0" kern="0">
+              <a:rPr lang="en-US" sz="2550" dirty="0" spc="1" kern="0">
                 <a:solidFill>
                   <a:srgbClr val="E4E1D8"/>
                 </a:solidFill>
@@ -14434,7 +14445,7 @@
               <a:t> quy</a:t>
             </a:r>
             <a:r>
-              <a:rPr lang="en-US" sz="2400" dirty="0" spc="-8" kern="0">
+              <a:rPr lang="en-US" sz="2550" dirty="0" spc="-8" kern="0">
                 <a:solidFill>
                   <a:srgbClr val="E4E1D8"/>
                 </a:solidFill>
@@ -14444,7 +14455,7 @@
               </a:rPr>
               <a:t> tắc.</a:t>
             </a:r>
-            <a:endParaRPr lang="en-US" sz="2400" dirty="0"/>
+            <a:endParaRPr lang="en-US" sz="2550" dirty="0"/>
           </a:p>
         </p:txBody>
       </p:sp>
@@ -14554,17 +14565,17 @@
           <a:ln/>
         </p:spPr>
         <p:txBody>
-          <a:bodyPr wrap="square" lIns="0" tIns="5334" rIns="0" bIns="-5334" rtlCol="0" anchor="t"/>
+          <a:bodyPr wrap="square" lIns="0" tIns="5667" rIns="0" bIns="-5667" rtlCol="0" anchor="t"/>
           <a:lstStyle/>
           <a:p>
             <a:pPr algn="l" indent="0" marL="0">
               <a:lnSpc>
-                <a:spcPts val="3360"/>
+                <a:spcPts val="3570"/>
               </a:lnSpc>
               <a:buNone/>
             </a:pPr>
             <a:r>
-              <a:rPr lang="en-US" sz="2400" dirty="0" spc="-3" kern="0">
+              <a:rPr lang="en-US" sz="2550" dirty="0" spc="-4" kern="0">
                 <a:solidFill>
                   <a:srgbClr val="E4E1D8"/>
                 </a:solidFill>
@@ -14575,7 +14586,7 @@
               <a:t>Theo</a:t>
             </a:r>
             <a:r>
-              <a:rPr lang="en-US" sz="2400" dirty="0" spc="1" kern="0">
+              <a:rPr lang="en-US" sz="2550" dirty="0" spc="-1" kern="0">
                 <a:solidFill>
                   <a:srgbClr val="E4E1D8"/>
                 </a:solidFill>
@@ -14583,10 +14594,10 @@
                 <a:ea typeface="Be Vietnam Pro" pitchFamily="34" charset="-122"/>
                 <a:cs typeface="Be Vietnam Pro" pitchFamily="34" charset="-120"/>
               </a:rPr>
-              <a:t> dõi tỉ lệ,</a:t>
-            </a:r>
-            <a:r>
-              <a:rPr lang="en-US" sz="2400" dirty="0" spc="-1" kern="0">
+              <a:t> dõi</a:t>
+            </a:r>
+            <a:r>
+              <a:rPr lang="en-US" sz="2550" dirty="0" spc="3" kern="0">
                 <a:solidFill>
                   <a:srgbClr val="E4E1D8"/>
                 </a:solidFill>
@@ -14594,10 +14605,10 @@
                 <a:ea typeface="Be Vietnam Pro" pitchFamily="34" charset="-122"/>
                 <a:cs typeface="Be Vietnam Pro" pitchFamily="34" charset="-120"/>
               </a:rPr>
-              <a:t> cách</a:t>
-            </a:r>
-            <a:r>
-              <a:rPr lang="en-US" sz="2400" dirty="0" spc="1" kern="0">
+              <a:t> tỉ</a:t>
+            </a:r>
+            <a:r>
+              <a:rPr lang="en-US" sz="2550" dirty="0" spc="0" kern="0">
                 <a:solidFill>
                   <a:srgbClr val="E4E1D8"/>
                 </a:solidFill>
@@ -14605,10 +14616,21 @@
                 <a:ea typeface="Be Vietnam Pro" pitchFamily="34" charset="-122"/>
                 <a:cs typeface="Be Vietnam Pro" pitchFamily="34" charset="-120"/>
               </a:rPr>
+              <a:t> lệ, cách</a:t>
+            </a:r>
+            <a:r>
+              <a:rPr lang="en-US" sz="2550" dirty="0" spc="-1" kern="0">
+                <a:solidFill>
+                  <a:srgbClr val="E4E1D8"/>
+                </a:solidFill>
+                <a:latin typeface="Be Vietnam Pro" pitchFamily="34" charset="0"/>
+                <a:ea typeface="Be Vietnam Pro" pitchFamily="34" charset="-122"/>
+                <a:cs typeface="Be Vietnam Pro" pitchFamily="34" charset="-120"/>
+              </a:rPr>
               <a:t> ly,</a:t>
             </a:r>
             <a:r>
-              <a:rPr lang="en-US" sz="2400" dirty="0" spc="11" kern="0">
+              <a:rPr lang="en-US" sz="2550" dirty="0" spc="7" kern="0">
                 <a:solidFill>
                   <a:srgbClr val="E4E1D8"/>
                 </a:solidFill>
@@ -14619,7 +14641,7 @@
               <a:t> sửa</a:t>
             </a:r>
             <a:r>
-              <a:rPr lang="en-US" sz="2400" dirty="0" spc="-12" kern="0">
+              <a:rPr lang="en-US" sz="2550" dirty="0" spc="-12" kern="0">
                 <a:solidFill>
                   <a:srgbClr val="E4E1D8"/>
                 </a:solidFill>
@@ -14630,7 +14652,7 @@
               <a:t> nguyên</a:t>
             </a:r>
             <a:r>
-              <a:rPr lang="en-US" sz="2400" dirty="0" spc="1" kern="0">
+              <a:rPr lang="en-US" sz="2550" dirty="0" spc="0" kern="0">
                 <a:solidFill>
                   <a:srgbClr val="E4E1D8"/>
                 </a:solidFill>
@@ -14640,7 +14662,7 @@
               </a:rPr>
               <a:t> nhân.</a:t>
             </a:r>
-            <a:endParaRPr lang="en-US" sz="2400" dirty="0"/>
+            <a:endParaRPr lang="en-US" sz="2550" dirty="0"/>
           </a:p>
         </p:txBody>
       </p:sp>
@@ -14739,17 +14761,17 @@
           <a:ln/>
         </p:spPr>
         <p:txBody>
-          <a:bodyPr wrap="square" lIns="0" tIns="5334" rIns="0" bIns="-5334" rtlCol="0" anchor="t"/>
+          <a:bodyPr wrap="square" lIns="0" tIns="5667" rIns="0" bIns="-5667" rtlCol="0" anchor="t"/>
           <a:lstStyle/>
           <a:p>
             <a:pPr algn="l" indent="0" marL="0">
               <a:lnSpc>
-                <a:spcPts val="3360"/>
+                <a:spcPts val="3570"/>
               </a:lnSpc>
               <a:buNone/>
             </a:pPr>
             <a:r>
-              <a:rPr lang="en-US" sz="2400" dirty="0" spc="2" kern="0">
+              <a:rPr lang="en-US" sz="2550" dirty="0" spc="-2" kern="0">
                 <a:solidFill>
                   <a:srgbClr val="E4E1D8"/>
                 </a:solidFill>
@@ -14757,10 +14779,10 @@
                 <a:ea typeface="Be Vietnam Pro" pitchFamily="34" charset="-122"/>
                 <a:cs typeface="Be Vietnam Pro" pitchFamily="34" charset="-120"/>
               </a:rPr>
-              <a:t>Kho bí</a:t>
-            </a:r>
-            <a:r>
-              <a:rPr lang="en-US" sz="2400" dirty="0" spc="-6" kern="0">
+              <a:t>Kho</a:t>
+            </a:r>
+            <a:r>
+              <a:rPr lang="en-US" sz="2550" dirty="0" spc="1" kern="0">
                 <a:solidFill>
                   <a:srgbClr val="E4E1D8"/>
                 </a:solidFill>
@@ -14768,10 +14790,21 @@
                 <a:ea typeface="Be Vietnam Pro" pitchFamily="34" charset="-122"/>
                 <a:cs typeface="Be Vietnam Pro" pitchFamily="34" charset="-120"/>
               </a:rPr>
+              <a:t> bí</a:t>
+            </a:r>
+            <a:r>
+              <a:rPr lang="en-US" sz="2550" dirty="0" spc="-9" kern="0">
+                <a:solidFill>
+                  <a:srgbClr val="E4E1D8"/>
+                </a:solidFill>
+                <a:latin typeface="Be Vietnam Pro" pitchFamily="34" charset="0"/>
+                <a:ea typeface="Be Vietnam Pro" pitchFamily="34" charset="-122"/>
+                <a:cs typeface="Be Vietnam Pro" pitchFamily="34" charset="-120"/>
+              </a:rPr>
               <a:t> mật,</a:t>
             </a:r>
             <a:r>
-              <a:rPr lang="en-US" sz="2400" dirty="0" spc="-15" kern="0">
+              <a:rPr lang="en-US" sz="2550" dirty="0" spc="-14" kern="0">
                 <a:solidFill>
                   <a:srgbClr val="E4E1D8"/>
                 </a:solidFill>
@@ -14782,7 +14815,7 @@
               <a:t> quyền</a:t>
             </a:r>
             <a:r>
-              <a:rPr lang="en-US" sz="2400" dirty="0" spc="-11" kern="0">
+              <a:rPr lang="en-US" sz="2550" dirty="0" spc="-13" kern="0">
                 <a:solidFill>
                   <a:srgbClr val="E4E1D8"/>
                 </a:solidFill>
@@ -14793,7 +14826,7 @@
               <a:t> tối</a:t>
             </a:r>
             <a:r>
-              <a:rPr lang="en-US" sz="2400" dirty="0" spc="0" kern="0">
+              <a:rPr lang="en-US" sz="2550" dirty="0" spc="1" kern="0">
                 <a:solidFill>
                   <a:srgbClr val="E4E1D8"/>
                 </a:solidFill>
@@ -14801,10 +14834,10 @@
                 <a:ea typeface="Be Vietnam Pro" pitchFamily="34" charset="-122"/>
                 <a:cs typeface="Be Vietnam Pro" pitchFamily="34" charset="-120"/>
               </a:rPr>
-              <a:t> thiểu, thời</a:t>
-            </a:r>
-            <a:r>
-              <a:rPr lang="en-US" sz="2400" dirty="0" spc="2" kern="0">
+              <a:t> thiểu,</a:t>
+            </a:r>
+            <a:r>
+              <a:rPr lang="en-US" sz="2550" dirty="0" spc="0" kern="0">
                 <a:solidFill>
                   <a:srgbClr val="E4E1D8"/>
                 </a:solidFill>
@@ -14812,10 +14845,10 @@
                 <a:ea typeface="Be Vietnam Pro" pitchFamily="34" charset="-122"/>
                 <a:cs typeface="Be Vietnam Pro" pitchFamily="34" charset="-120"/>
               </a:rPr>
-              <a:t> hạn</a:t>
-            </a:r>
-            <a:r>
-              <a:rPr lang="en-US" sz="2400" dirty="0" spc="-6" kern="0">
+              <a:t> thời hạn</a:t>
+            </a:r>
+            <a:r>
+              <a:rPr lang="en-US" sz="2550" dirty="0" spc="-8" kern="0">
                 <a:solidFill>
                   <a:srgbClr val="E4E1D8"/>
                 </a:solidFill>
@@ -14825,7 +14858,7 @@
               </a:rPr>
               <a:t> ngắn.</a:t>
             </a:r>
-            <a:endParaRPr lang="en-US" sz="2400" dirty="0"/>
+            <a:endParaRPr lang="en-US" sz="2550" dirty="0"/>
           </a:p>
         </p:txBody>
       </p:sp>
@@ -14935,17 +14968,17 @@
           <a:ln/>
         </p:spPr>
         <p:txBody>
-          <a:bodyPr wrap="square" lIns="0" tIns="5334" rIns="0" bIns="-5334" rtlCol="0" anchor="t"/>
+          <a:bodyPr wrap="square" lIns="0" tIns="5667" rIns="0" bIns="-5667" rtlCol="0" anchor="t"/>
           <a:lstStyle/>
           <a:p>
             <a:pPr algn="l" indent="0" marL="0">
               <a:lnSpc>
-                <a:spcPts val="3360"/>
+                <a:spcPts val="3570"/>
               </a:lnSpc>
               <a:buNone/>
             </a:pPr>
             <a:r>
-              <a:rPr lang="en-US" sz="2400" dirty="0" spc="-1" kern="0">
+              <a:rPr lang="en-US" sz="2550" dirty="0" spc="-5" kern="0">
                 <a:solidFill>
                   <a:srgbClr val="E4E1D8"/>
                 </a:solidFill>
@@ -14956,7 +14989,7 @@
               <a:t>Khóa</a:t>
             </a:r>
             <a:r>
-              <a:rPr lang="en-US" sz="2400" dirty="0" spc="0" kern="0">
+              <a:rPr lang="en-US" sz="2550" dirty="0" spc="0" kern="0">
                 <a:solidFill>
                   <a:srgbClr val="E4E1D8"/>
                 </a:solidFill>
@@ -14964,10 +14997,10 @@
                 <a:ea typeface="Be Vietnam Pro" pitchFamily="34" charset="-122"/>
                 <a:cs typeface="Be Vietnam Pro" pitchFamily="34" charset="-120"/>
               </a:rPr>
-              <a:t> phiên bản,</a:t>
-            </a:r>
-            <a:r>
-              <a:rPr lang="en-US" sz="2400" dirty="0" spc="-1" kern="0">
+              <a:t> phiên</a:t>
+            </a:r>
+            <a:r>
+              <a:rPr lang="en-US" sz="2550" dirty="0" spc="-3" kern="0">
                 <a:solidFill>
                   <a:srgbClr val="E4E1D8"/>
                 </a:solidFill>
@@ -14975,10 +15008,21 @@
                 <a:ea typeface="Be Vietnam Pro" pitchFamily="34" charset="-122"/>
                 <a:cs typeface="Be Vietnam Pro" pitchFamily="34" charset="-120"/>
               </a:rPr>
+              <a:t> bản,</a:t>
+            </a:r>
+            <a:r>
+              <a:rPr lang="en-US" sz="2550" dirty="0" spc="1" kern="0">
+                <a:solidFill>
+                  <a:srgbClr val="E4E1D8"/>
+                </a:solidFill>
+                <a:latin typeface="Be Vietnam Pro" pitchFamily="34" charset="0"/>
+                <a:ea typeface="Be Vietnam Pro" pitchFamily="34" charset="-122"/>
+                <a:cs typeface="Be Vietnam Pro" pitchFamily="34" charset="-120"/>
+              </a:rPr>
               <a:t> kiểm</a:t>
             </a:r>
             <a:r>
-              <a:rPr lang="en-US" sz="2400" dirty="0" spc="-21" kern="0">
+              <a:rPr lang="en-US" sz="2550" dirty="0" spc="-25" kern="0">
                 <a:solidFill>
                   <a:srgbClr val="E4E1D8"/>
                 </a:solidFill>
@@ -14989,7 +15033,7 @@
               <a:t> tra</a:t>
             </a:r>
             <a:r>
-              <a:rPr lang="en-US" sz="2400" dirty="0" spc="1" kern="0">
+              <a:rPr lang="en-US" sz="2550" dirty="0" spc="0" kern="0">
                 <a:solidFill>
                   <a:srgbClr val="E4E1D8"/>
                 </a:solidFill>
@@ -15000,7 +15044,7 @@
               <a:t> nguồn</a:t>
             </a:r>
             <a:r>
-              <a:rPr lang="en-US" sz="2400" dirty="0" spc="-13" kern="0">
+              <a:rPr lang="en-US" sz="2550" dirty="0" spc="-15" kern="0">
                 <a:solidFill>
                   <a:srgbClr val="E4E1D8"/>
                 </a:solidFill>
@@ -15011,7 +15055,7 @@
               <a:t> gốc</a:t>
             </a:r>
             <a:r>
-              <a:rPr lang="en-US" sz="2400" dirty="0" spc="-1" kern="0">
+              <a:rPr lang="en-US" sz="2550" dirty="0" spc="1" kern="0">
                 <a:solidFill>
                   <a:srgbClr val="E4E1D8"/>
                 </a:solidFill>
@@ -15021,7 +15065,7 @@
               </a:rPr>
               <a:t> build.</a:t>
             </a:r>
-            <a:endParaRPr lang="en-US" sz="2400" dirty="0"/>
+            <a:endParaRPr lang="en-US" sz="2550" dirty="0"/>
           </a:p>
         </p:txBody>
       </p:sp>

</xml_diff>

<commit_message>
Slides: sd-13 content tables at 34 px, 013 bridge rule qualified, 015 terms on the closing slide
Co-Authored-By: Claude Opus 5.5 <noreply@anthropic.com>
Claude-Session: https://claude.ai/code/session_01TQmrJYLm4GPgtXpQaEk7ey
</commit_message>
<xml_diff>
--- a/system-design-101/vi/lessons/sd-13-012/slides/sd-13-012.pptx
+++ b/system-design-101/vi/lessons/sd-13-012/slides/sd-13-012.pptx
@@ -12656,12 +12656,12 @@
                     <a:p>
                       <a:pPr algn="l" indent="0" marL="0">
                         <a:lnSpc>
-                          <a:spcPts val="2880"/>
+                          <a:spcPts val="3060"/>
                         </a:lnSpc>
                         <a:buNone/>
                       </a:pPr>
                       <a:r>
-                        <a:rPr lang="en-US" sz="2400" b="1" dirty="0" spc="-6" kern="0">
+                        <a:rPr lang="en-US" sz="2550" b="1" dirty="0" spc="-2" kern="0">
                           <a:solidFill>
                             <a:srgbClr val="14161C"/>
                           </a:solidFill>
@@ -12672,7 +12672,7 @@
                         <a:t>Image</a:t>
                       </a:r>
                       <a:r>
-                        <a:rPr lang="en-US" sz="2400" b="1" dirty="0" spc="0" kern="0">
+                        <a:rPr lang="en-US" sz="2550" b="1" dirty="0" spc="1" kern="0">
                           <a:solidFill>
                             <a:srgbClr val="14161C"/>
                           </a:solidFill>
@@ -12683,7 +12683,7 @@
                         <a:t> giữ</a:t>
                       </a:r>
                       <a:r>
-                        <a:rPr lang="en-US" sz="2400" b="1" dirty="0" spc="-4" kern="0">
+                        <a:rPr lang="en-US" sz="2550" b="1" dirty="0" spc="-4" kern="0">
                           <a:solidFill>
                             <a:srgbClr val="14161C"/>
                           </a:solidFill>
@@ -12694,7 +12694,7 @@
                         <a:t> cố</a:t>
                       </a:r>
                       <a:r>
-                        <a:rPr lang="en-US" sz="2400" b="1" dirty="0" spc="14" kern="0">
+                        <a:rPr lang="en-US" sz="2550" b="1" dirty="0" spc="12" kern="0">
                           <a:solidFill>
                             <a:srgbClr val="14161C"/>
                           </a:solidFill>
@@ -12732,12 +12732,12 @@
                     <a:p>
                       <a:pPr algn="l" indent="0" marL="0">
                         <a:lnSpc>
-                          <a:spcPts val="2880"/>
+                          <a:spcPts val="3060"/>
                         </a:lnSpc>
                         <a:buNone/>
                       </a:pPr>
                       <a:r>
-                        <a:rPr lang="en-US" sz="2400" b="1" dirty="0" spc="-45" kern="0">
+                        <a:rPr lang="en-US" sz="2550" b="1" dirty="0" spc="-48" kern="0">
                           <a:solidFill>
                             <a:srgbClr val="14161C"/>
                           </a:solidFill>
@@ -12748,7 +12748,7 @@
                         <a:t>Vẫn</a:t>
                       </a:r>
                       <a:r>
-                        <a:rPr lang="en-US" sz="2400" b="1" dirty="0" spc="-4" kern="0">
+                        <a:rPr lang="en-US" sz="2550" b="1" dirty="0" spc="-3" kern="0">
                           <a:solidFill>
                             <a:srgbClr val="14161C"/>
                           </a:solidFill>
@@ -12756,10 +12756,21 @@
                           <a:ea typeface="Be Vietnam Pro" pitchFamily="34" charset="-122"/>
                           <a:cs typeface="Be Vietnam Pro" pitchFamily="34" charset="-120"/>
                         </a:rPr>
-                        <a:t> có thể</a:t>
+                        <a:t> có</a:t>
                       </a:r>
                       <a:r>
-                        <a:rPr lang="en-US" sz="2400" b="1" dirty="0" spc="1" kern="0">
+                        <a:rPr lang="en-US" sz="2550" b="1" dirty="0" spc="-2" kern="0">
+                          <a:solidFill>
+                            <a:srgbClr val="14161C"/>
+                          </a:solidFill>
+                          <a:latin typeface="Be Vietnam Pro" pitchFamily="34" charset="0"/>
+                          <a:ea typeface="Be Vietnam Pro" pitchFamily="34" charset="-122"/>
+                          <a:cs typeface="Be Vietnam Pro" pitchFamily="34" charset="-120"/>
+                        </a:rPr>
+                        <a:t> thể</a:t>
+                      </a:r>
+                      <a:r>
+                        <a:rPr lang="en-US" sz="2550" b="1" dirty="0" spc="0" kern="0">
                           <a:solidFill>
                             <a:srgbClr val="14161C"/>
                           </a:solidFill>
@@ -12770,7 +12781,7 @@
                         <a:t> khác,</a:t>
                       </a:r>
                       <a:r>
-                        <a:rPr lang="en-US" sz="2400" b="1" dirty="0" spc="-4" kern="0">
+                        <a:rPr lang="en-US" sz="2550" b="1" dirty="0" spc="-2" kern="0">
                           <a:solidFill>
                             <a:srgbClr val="14161C"/>
                           </a:solidFill>
@@ -12781,7 +12792,7 @@
                         <a:t> kiểm</a:t>
                       </a:r>
                       <a:r>
-                        <a:rPr lang="en-US" sz="2400" b="1" dirty="0" spc="-10" kern="0">
+                        <a:rPr lang="en-US" sz="2550" b="1" dirty="0" spc="-14" kern="0">
                           <a:solidFill>
                             <a:srgbClr val="14161C"/>
                           </a:solidFill>
@@ -12792,7 +12803,7 @@
                         <a:t> tra</a:t>
                       </a:r>
                       <a:r>
-                        <a:rPr lang="en-US" sz="2400" b="1" dirty="0" spc="-1" kern="0">
+                        <a:rPr lang="en-US" sz="2550" b="1" dirty="0" spc="2" kern="0">
                           <a:solidFill>
                             <a:srgbClr val="14161C"/>
                           </a:solidFill>
@@ -12838,12 +12849,12 @@
                     <a:p>
                       <a:pPr algn="l" indent="0" marL="0">
                         <a:lnSpc>
-                          <a:spcPts val="2880"/>
+                          <a:spcPts val="3060"/>
                         </a:lnSpc>
                         <a:buNone/>
                       </a:pPr>
                       <a:r>
-                        <a:rPr lang="en-US" sz="2400" dirty="0" spc="4" kern="0">
+                        <a:rPr lang="en-US" sz="2550" dirty="0" spc="-2" kern="0">
                           <a:solidFill>
                             <a:srgbClr val="14161C"/>
                           </a:solidFill>
@@ -12854,7 +12865,7 @@
                         <a:t>Đúng</a:t>
                       </a:r>
                       <a:r>
-                        <a:rPr lang="en-US" sz="2400" dirty="0" spc="-1" kern="0">
+                        <a:rPr lang="en-US" sz="2550" dirty="0" spc="-3" kern="0">
                           <a:solidFill>
                             <a:srgbClr val="14161C"/>
                           </a:solidFill>
@@ -12865,7 +12876,7 @@
                         <a:t> bản</a:t>
                       </a:r>
                       <a:r>
-                        <a:rPr lang="en-US" sz="2400" dirty="0" spc="19" kern="0">
+                        <a:rPr lang="en-US" sz="2550" dirty="0" spc="18" kern="0">
                           <a:solidFill>
                             <a:srgbClr val="14161C"/>
                           </a:solidFill>
@@ -12876,7 +12887,7 @@
                         <a:t> đã</a:t>
                       </a:r>
                       <a:r>
-                        <a:rPr lang="en-US" sz="2400" dirty="0" spc="-1" kern="0">
+                        <a:rPr lang="en-US" sz="2550" dirty="0" spc="1" kern="0">
                           <a:solidFill>
                             <a:srgbClr val="14161C"/>
                           </a:solidFill>
@@ -12887,7 +12898,7 @@
                         <a:t> kiểm</a:t>
                       </a:r>
                       <a:r>
-                        <a:rPr lang="en-US" sz="2400" dirty="0" spc="3" kern="0">
+                        <a:rPr lang="en-US" sz="2550" dirty="0" spc="-1" kern="0">
                           <a:solidFill>
                             <a:srgbClr val="14161C"/>
                           </a:solidFill>
@@ -12931,12 +12942,12 @@
                     <a:p>
                       <a:pPr algn="l" indent="0" marL="0">
                         <a:lnSpc>
-                          <a:spcPts val="2880"/>
+                          <a:spcPts val="3060"/>
                         </a:lnSpc>
                         <a:buNone/>
                       </a:pPr>
                       <a:r>
-                        <a:rPr lang="en-US" sz="2400" dirty="0" spc="-1" kern="0">
+                        <a:rPr lang="en-US" sz="2550" dirty="0" spc="3" kern="0">
                           <a:solidFill>
                             <a:srgbClr val="14161C"/>
                           </a:solidFill>
@@ -12947,7 +12958,7 @@
                         <a:t>Cấu</a:t>
                       </a:r>
                       <a:r>
-                        <a:rPr lang="en-US" sz="2400" dirty="0" spc="0" kern="0">
+                        <a:rPr lang="en-US" sz="2550" dirty="0" spc="0" kern="0">
                           <a:solidFill>
                             <a:srgbClr val="14161C"/>
                           </a:solidFill>
@@ -12958,7 +12969,7 @@
                         <a:t> hình</a:t>
                       </a:r>
                       <a:r>
-                        <a:rPr lang="en-US" sz="2400" dirty="0" spc="-11" kern="0">
+                        <a:rPr lang="en-US" sz="2550" dirty="0" spc="-11" kern="0">
                           <a:solidFill>
                             <a:srgbClr val="14161C"/>
                           </a:solidFill>
@@ -12969,7 +12980,7 @@
                         <a:t> truyền</a:t>
                       </a:r>
                       <a:r>
-                        <a:rPr lang="en-US" sz="2400" dirty="0" spc="0" kern="0">
+                        <a:rPr lang="en-US" sz="2550" dirty="0" spc="-2" kern="0">
                           <a:solidFill>
                             <a:srgbClr val="14161C"/>
                           </a:solidFill>
@@ -12980,7 +12991,7 @@
                         <a:t> lúc</a:t>
                       </a:r>
                       <a:r>
-                        <a:rPr lang="en-US" sz="2400" dirty="0" spc="-7" kern="0">
+                        <a:rPr lang="en-US" sz="2550" dirty="0" spc="-8" kern="0">
                           <a:solidFill>
                             <a:srgbClr val="14161C"/>
                           </a:solidFill>
@@ -13032,12 +13043,12 @@
                     <a:p>
                       <a:pPr algn="l" indent="0" marL="0">
                         <a:lnSpc>
-                          <a:spcPts val="2880"/>
+                          <a:spcPts val="3060"/>
                         </a:lnSpc>
                         <a:buNone/>
                       </a:pPr>
                       <a:r>
-                        <a:rPr lang="en-US" sz="2400" dirty="0" spc="2" kern="0">
+                        <a:rPr lang="en-US" sz="2550" dirty="0" spc="-1" kern="0">
                           <a:solidFill>
                             <a:srgbClr val="14161C"/>
                           </a:solidFill>
@@ -13048,7 +13059,7 @@
                         <a:t>Không</a:t>
                       </a:r>
                       <a:r>
-                        <a:rPr lang="en-US" sz="2400" dirty="0" spc="-3" kern="0">
+                        <a:rPr lang="en-US" sz="2550" dirty="0" spc="-2" kern="0">
                           <a:solidFill>
                             <a:srgbClr val="14161C"/>
                           </a:solidFill>
@@ -13059,7 +13070,7 @@
                         <a:t> lệch</a:t>
                       </a:r>
                       <a:r>
-                        <a:rPr lang="en-US" sz="2400" dirty="0" spc="3" kern="0">
+                        <a:rPr lang="en-US" sz="2550" dirty="0" spc="-1" kern="0">
                           <a:solidFill>
                             <a:srgbClr val="14161C"/>
                           </a:solidFill>
@@ -13070,7 +13081,7 @@
                         <a:t> do</a:t>
                       </a:r>
                       <a:r>
-                        <a:rPr lang="en-US" sz="2400" dirty="0" spc="10" kern="0">
+                        <a:rPr lang="en-US" sz="2550" dirty="0" spc="7" kern="0">
                           <a:solidFill>
                             <a:srgbClr val="14161C"/>
                           </a:solidFill>
@@ -13081,7 +13092,7 @@
                         <a:t> sửa</a:t>
                       </a:r>
                       <a:r>
-                        <a:rPr lang="en-US" sz="2400" dirty="0" spc="-10" kern="0">
+                        <a:rPr lang="en-US" sz="2550" dirty="0" spc="-12" kern="0">
                           <a:solidFill>
                             <a:srgbClr val="14161C"/>
                           </a:solidFill>
@@ -13092,7 +13103,7 @@
                         <a:t> tại</a:t>
                       </a:r>
                       <a:r>
-                        <a:rPr lang="en-US" sz="2400" dirty="0" spc="-1" kern="0">
+                        <a:rPr lang="en-US" sz="2550" dirty="0" spc="0" kern="0">
                           <a:solidFill>
                             <a:srgbClr val="14161C"/>
                           </a:solidFill>
@@ -13136,12 +13147,12 @@
                     <a:p>
                       <a:pPr algn="l" indent="0" marL="0">
                         <a:lnSpc>
-                          <a:spcPts val="2880"/>
+                          <a:spcPts val="3060"/>
                         </a:lnSpc>
                         <a:buNone/>
                       </a:pPr>
                       <a:r>
-                        <a:rPr lang="en-US" sz="2400" dirty="0" spc="2" kern="0">
+                        <a:rPr lang="en-US" sz="2550" dirty="0" spc="-6" kern="0">
                           <a:solidFill>
                             <a:srgbClr val="14161C"/>
                           </a:solidFill>
@@ -13152,7 +13163,7 @@
                         <a:t>Dữ</a:t>
                       </a:r>
                       <a:r>
-                        <a:rPr lang="en-US" sz="2400" dirty="0" spc="-1" kern="0">
+                        <a:rPr lang="en-US" sz="2550" dirty="0" spc="1" kern="0">
                           <a:solidFill>
                             <a:srgbClr val="14161C"/>
                           </a:solidFill>
@@ -13160,10 +13171,21 @@
                           <a:ea typeface="Be Vietnam Pro" pitchFamily="34" charset="-122"/>
                           <a:cs typeface="Be Vietnam Pro" pitchFamily="34" charset="-120"/>
                         </a:rPr>
-                        <a:t> liệu, loại</a:t>
+                        <a:t> liệu,</a:t>
                       </a:r>
                       <a:r>
-                        <a:rPr lang="en-US" sz="2400" dirty="0" spc="-5" kern="0">
+                        <a:rPr lang="en-US" sz="2550" dirty="0" spc="-3" kern="0">
+                          <a:solidFill>
+                            <a:srgbClr val="14161C"/>
+                          </a:solidFill>
+                          <a:latin typeface="Be Vietnam Pro" pitchFamily="34" charset="0"/>
+                          <a:ea typeface="Be Vietnam Pro" pitchFamily="34" charset="-122"/>
+                          <a:cs typeface="Be Vietnam Pro" pitchFamily="34" charset="-120"/>
+                        </a:rPr>
+                        <a:t> loại</a:t>
+                      </a:r>
+                      <a:r>
+                        <a:rPr lang="en-US" sz="2550" dirty="0" spc="-7" kern="0">
                           <a:solidFill>
                             <a:srgbClr val="14161C"/>
                           </a:solidFill>
@@ -13174,7 +13196,7 @@
                         <a:t> máy,</a:t>
                       </a:r>
                       <a:r>
-                        <a:rPr lang="en-US" sz="2400" dirty="0" spc="4" kern="0">
+                        <a:rPr lang="en-US" sz="2550" dirty="0" spc="0" kern="0">
                           <a:solidFill>
                             <a:srgbClr val="14161C"/>
                           </a:solidFill>
@@ -13226,12 +13248,12 @@
                     <a:p>
                       <a:pPr algn="l" indent="0" marL="0">
                         <a:lnSpc>
-                          <a:spcPts val="2880"/>
+                          <a:spcPts val="3060"/>
                         </a:lnSpc>
                         <a:buNone/>
                       </a:pPr>
                       <a:r>
-                        <a:rPr lang="en-US" sz="2400" dirty="0" spc="-10" kern="0">
+                        <a:rPr lang="en-US" sz="2550" dirty="0" spc="-9" kern="0">
                           <a:solidFill>
                             <a:srgbClr val="14161C"/>
                           </a:solidFill>
@@ -13242,7 +13264,7 @@
                         <a:t>Quay</a:t>
                       </a:r>
                       <a:r>
-                        <a:rPr lang="en-US" sz="2400" dirty="0" spc="-1" kern="0">
+                        <a:rPr lang="en-US" sz="2550" dirty="0" spc="1" kern="0">
                           <a:solidFill>
                             <a:srgbClr val="14161C"/>
                           </a:solidFill>
@@ -13253,7 +13275,7 @@
                         <a:t> lui:</a:t>
                       </a:r>
                       <a:r>
-                        <a:rPr lang="en-US" sz="2400" dirty="0" spc="-6" kern="0">
+                        <a:rPr lang="en-US" sz="2550" dirty="0" spc="-7" kern="0">
                           <a:solidFill>
                             <a:srgbClr val="14161C"/>
                           </a:solidFill>
@@ -13264,7 +13286,7 @@
                         <a:t> thay</a:t>
                       </a:r>
                       <a:r>
-                        <a:rPr lang="en-US" sz="2400" dirty="0" spc="0" kern="0">
+                        <a:rPr lang="en-US" sz="2550" dirty="0" spc="0" kern="0">
                           <a:solidFill>
                             <a:srgbClr val="14161C"/>
                           </a:solidFill>
@@ -13275,7 +13297,7 @@
                         <a:t> lại</a:t>
                       </a:r>
                       <a:r>
-                        <a:rPr lang="en-US" sz="2400" dirty="0" spc="-6" kern="0">
+                        <a:rPr lang="en-US" sz="2550" dirty="0" spc="-8" kern="0">
                           <a:solidFill>
                             <a:srgbClr val="14161C"/>
                           </a:solidFill>
@@ -13286,7 +13308,7 @@
                         <a:t> image</a:t>
                       </a:r>
                       <a:r>
-                        <a:rPr lang="en-US" sz="2400" dirty="0" spc="6" kern="0">
+                        <a:rPr lang="en-US" sz="2550" dirty="0" spc="6" kern="0">
                           <a:solidFill>
                             <a:srgbClr val="14161C"/>
                           </a:solidFill>
@@ -13330,12 +13352,12 @@
                     <a:p>
                       <a:pPr algn="l" indent="0" marL="0">
                         <a:lnSpc>
-                          <a:spcPts val="2880"/>
+                          <a:spcPts val="3060"/>
                         </a:lnSpc>
                         <a:buNone/>
                       </a:pPr>
                       <a:r>
-                        <a:rPr lang="en-US" sz="2400" dirty="0" spc="-1" kern="0">
+                        <a:rPr lang="en-US" sz="2550" dirty="0" spc="2" kern="0">
                           <a:solidFill>
                             <a:srgbClr val="14161C"/>
                           </a:solidFill>
@@ -13346,7 +13368,7 @@
                         <a:t>Các</a:t>
                       </a:r>
                       <a:r>
-                        <a:rPr lang="en-US" sz="2400" dirty="0" spc="0" kern="0">
+                        <a:rPr lang="en-US" sz="2550" dirty="0" spc="0" kern="0">
                           <a:solidFill>
                             <a:srgbClr val="14161C"/>
                           </a:solidFill>
@@ -13357,7 +13379,7 @@
                         <a:t> dịch</a:t>
                       </a:r>
                       <a:r>
-                        <a:rPr lang="en-US" sz="2400" dirty="0" spc="1" kern="0">
+                        <a:rPr lang="en-US" sz="2550" dirty="0" spc="-4" kern="0">
                           <a:solidFill>
                             <a:srgbClr val="14161C"/>
                           </a:solidFill>
@@ -13368,7 +13390,7 @@
                         <a:t> vụ</a:t>
                       </a:r>
                       <a:r>
-                        <a:rPr lang="en-US" sz="2400" dirty="0" spc="2" kern="0">
+                        <a:rPr lang="en-US" sz="2550" dirty="0" spc="1" kern="0">
                           <a:solidFill>
                             <a:srgbClr val="14161C"/>
                           </a:solidFill>
@@ -13376,18 +13398,7 @@
                           <a:ea typeface="Be Vietnam Pro" pitchFamily="34" charset="-122"/>
                           <a:cs typeface="Be Vietnam Pro" pitchFamily="34" charset="-120"/>
                         </a:rPr>
-                        <a:t> xung</a:t>
-                      </a:r>
-                      <a:r>
-                        <a:rPr lang="en-US" sz="2400" dirty="0" spc="0" kern="0">
-                          <a:solidFill>
-                            <a:srgbClr val="14161C"/>
-                          </a:solidFill>
-                          <a:latin typeface="Be Vietnam Pro" pitchFamily="34" charset="0"/>
-                          <a:ea typeface="Be Vietnam Pro" pitchFamily="34" charset="-122"/>
-                          <a:cs typeface="Be Vietnam Pro" pitchFamily="34" charset="-120"/>
-                        </a:rPr>
-                        <a:t> quanh</a:t>
+                        <a:t> xung quanh</a:t>
                       </a:r>
                       <a:endParaRPr lang="en-US" sz="1200" dirty="0"/>
                     </a:p>

</xml_diff>